<commit_message>
Add morning-shift placement slides (shift design + carrier matrix)
Inserts 2 slides before 支店長・所属長の皆さんへ (pages shift +2):
- シフトの設計: early shift A (05:45-10:15) and mid shift B (07:30-12:00)
  sized to the two morning waves, with a timeline overlay marking the
  opening wave (05:55), the 08:30 peak (11 flights), and the 11:15 tail
- キャリア×時間帯の割付: AM/VN/VJ/5J/UL/RF mapped to shift A and/or B
  from real schedule times; required headcount left to each branch

Speaker-note scripts embedded on both slides.

Co-Authored-By: Claude Opus 4.8 <noreply@anthropic.com>
Claude-Session: https://claude.ai/code/session_01QArHsAp1PFHsh5bJQQbheX
</commit_message>
<xml_diff>
--- a/成田_短時間勤務者採用_説明会.pptx
+++ b/成田_短時間勤務者採用_説明会.pptx
@@ -26,6 +26,8 @@
     <p:sldId id="268" r:id="rId14"/>
     <p:sldId id="269" r:id="rId15"/>
     <p:sldId id="270" r:id="rId16"/>
+    <p:sldId id="282" r:id="rId33"/>
+    <p:sldId id="283" r:id="rId34"/>
     <p:sldId id="271" r:id="rId17"/>
     <p:sldId id="272" r:id="rId18"/>
     <p:sldId id="273" r:id="rId19"/>
@@ -3280,6 +3282,171 @@
 </p:notes>
 </file>
 
+<file path=ppt/notesSlides/notesSlide27.xml><?xml version="1.0" encoding="utf-8"?>
+<p:notes xmlns:a="http://schemas.openxmlformats.org/drawingml/2006/main" xmlns:p="http://schemas.openxmlformats.org/presentationml/2006/main" xmlns:r="http://schemas.openxmlformats.org/officeDocument/2006/relationships">
+  <p:cSld>
+    <p:spTree>
+      <p:nvGrpSpPr>
+        <p:cNvPr id="1" name=""/>
+        <p:cNvGrpSpPr/>
+        <p:nvPr/>
+      </p:nvGrpSpPr>
+      <p:grpSpPr>
+        <a:xfrm>
+          <a:off x="0" y="0"/>
+          <a:ext cx="0" cy="0"/>
+          <a:chOff x="0" y="0"/>
+          <a:chExt cx="0" cy="0"/>
+        </a:xfrm>
+      </p:grpSpPr>
+      <p:sp>
+        <p:nvSpPr>
+          <p:cNvPr id="2" name="Slide Image Placeholder 1"/>
+          <p:cNvSpPr>
+            <a:spLocks noGrp="1"/>
+          </p:cNvSpPr>
+          <p:nvPr>
+            <p:ph type="sldImg" idx="2"/>
+          </p:nvPr>
+        </p:nvSpPr>
+        <p:spPr/>
+      </p:sp>
+      <p:sp>
+        <p:nvSpPr>
+          <p:cNvPr id="3" name="Notes Placeholder 2"/>
+          <p:cNvSpPr>
+            <a:spLocks noGrp="1"/>
+          </p:cNvSpPr>
+          <p:nvPr>
+            <p:ph type="body" idx="3" sz="quarter"/>
+          </p:nvPr>
+        </p:nvSpPr>
+        <p:spPr/>
+        <p:txBody>
+          <a:bodyPr/>
+          <a:lstStyle/>
+          <a:p>
+            <a:r>
+              <a:t>ここからは、では実際に“どのキャリアの、どの時間帯に”短時間勤務者を入れていくか、という具体の話に入ります。対象はAM・VN・RF・5J・UL・VJの6社、すべて朝の便です。</a:t>
+            </a:r>
+          </a:p>
+          <a:p>
+            <a:r>
+              <a:t>線表を見ると、朝の山は実は一つではありません。まず6時前後に、出発カウンターの開設が一斉に立ち上がる“開設の波”。そして7時半から9時半にかけて、到着と折り返しが重なる“到着の波”。ピークは8時半で、同時に11便が動いています。</a:t>
+            </a:r>
+          </a:p>
+          <a:p>
+            <a:r>
+              <a:t>そこで短時間のシフトを二本立てで考えています。一つが早番、5時45分から10時15分。開設と到着の前半をカバー。もう一つが中番、7時半から12時。到着ピークと、10時半以降に残る後半の出発をカバーします。いずれも4時間半で、週20時間未満に収まります。</a:t>
+            </a:r>
+          </a:p>
+          <a:p>
+            <a:r>
+              <a:t>重なる7時半から10時過ぎが一番人手が要る時間なので、早番と中番の二枚重ねでここを厚くする設計です。</a:t>
+            </a:r>
+          </a:p>
+        </p:txBody>
+      </p:sp>
+      <p:sp>
+        <p:nvSpPr>
+          <p:cNvPr id="4" name="Slide Number Placeholder 3"/>
+          <p:cNvSpPr>
+            <a:spLocks noGrp="1"/>
+          </p:cNvSpPr>
+          <p:nvPr>
+            <p:ph type="sldNum" idx="5" sz="quarter"/>
+          </p:nvPr>
+        </p:nvSpPr>
+        <p:spPr/>
+      </p:sp>
+    </p:spTree>
+  </p:cSld>
+  <p:clrMapOvr>
+    <a:masterClrMapping/>
+  </p:clrMapOvr>
+</p:notes>
+</file>
+
+<file path=ppt/notesSlides/notesSlide28.xml><?xml version="1.0" encoding="utf-8"?>
+<p:notes xmlns:a="http://schemas.openxmlformats.org/drawingml/2006/main" xmlns:p="http://schemas.openxmlformats.org/presentationml/2006/main" xmlns:r="http://schemas.openxmlformats.org/officeDocument/2006/relationships">
+  <p:cSld>
+    <p:spTree>
+      <p:nvGrpSpPr>
+        <p:cNvPr id="1" name=""/>
+        <p:cNvGrpSpPr/>
+        <p:nvPr/>
+      </p:nvGrpSpPr>
+      <p:grpSpPr>
+        <a:xfrm>
+          <a:off x="0" y="0"/>
+          <a:ext cx="0" cy="0"/>
+          <a:chOff x="0" y="0"/>
+          <a:chExt cx="0" cy="0"/>
+        </a:xfrm>
+      </p:grpSpPr>
+      <p:sp>
+        <p:nvSpPr>
+          <p:cNvPr id="2" name="Slide Image Placeholder 1"/>
+          <p:cNvSpPr>
+            <a:spLocks noGrp="1"/>
+          </p:cNvSpPr>
+          <p:nvPr>
+            <p:ph type="sldImg" idx="2"/>
+          </p:nvPr>
+        </p:nvSpPr>
+        <p:spPr/>
+      </p:sp>
+      <p:sp>
+        <p:nvSpPr>
+          <p:cNvPr id="3" name="Notes Placeholder 2"/>
+          <p:cNvSpPr>
+            <a:spLocks noGrp="1"/>
+          </p:cNvSpPr>
+          <p:nvPr>
+            <p:ph type="body" idx="3" sz="quarter"/>
+          </p:nvPr>
+        </p:nvSpPr>
+        <p:spPr/>
+        <p:txBody>
+          <a:bodyPr/>
+          <a:lstStyle/>
+          <a:p>
+            <a:r>
+              <a:t>この二本に、6社を割り付けます。早番には、AM、そしてVN・VJ・5Jの前半便。だいたい9時半までに一巡します。中番には、UL、RF、それからVNの遅い便と5Jの遅い便。</a:t>
+            </a:r>
+          </a:p>
+          <a:p>
+            <a:r>
+              <a:t>一点はっきりさせておきたいのは、私たちが今日お見せしているのは“何時に、どのキャリアが動くか”までだということです。“では各シフトに何人か”は、ここで人事が勝手に決めません。実際の必要人数は、皆さんの支店で、この線表とSLA上の必要配置を突き合わせて出していただきます。人事は、その受け皿として募集・時給・教育・受入を用意します。</a:t>
+            </a:r>
+          </a:p>
+          <a:p>
+            <a:r>
+              <a:t>例外はVJです。VJには夕方の便もありますが、Winterで運休する場合は朝だけが対象。運航が残る場合は夕方帯を別途検討します。</a:t>
+            </a:r>
+          </a:p>
+        </p:txBody>
+      </p:sp>
+      <p:sp>
+        <p:nvSpPr>
+          <p:cNvPr id="4" name="Slide Number Placeholder 3"/>
+          <p:cNvSpPr>
+            <a:spLocks noGrp="1"/>
+          </p:cNvSpPr>
+          <p:nvPr>
+            <p:ph type="sldNum" idx="5" sz="quarter"/>
+          </p:nvPr>
+        </p:nvSpPr>
+        <p:spPr/>
+      </p:sp>
+    </p:spTree>
+  </p:cSld>
+  <p:clrMapOvr>
+    <a:masterClrMapping/>
+  </p:clrMapOvr>
+</p:notes>
+</file>
+
 <file path=ppt/notesSlides/notesSlide3.xml><?xml version="1.0" encoding="utf-8"?>
 <p:notes xmlns:a="http://schemas.openxmlformats.org/drawingml/2006/main" xmlns:r="http://schemas.openxmlformats.org/officeDocument/2006/relationships" xmlns:p="http://schemas.openxmlformats.org/presentationml/2006/main">
   <p:cSld>
@@ -6350,7 +6517,7 @@
                 </a:solidFill>
                 <a:latin typeface="Meiryo"/>
               </a:rPr>
-              <a:t>20</a:t>
+              <a:t>22</a:t>
             </a:r>
           </a:p>
         </p:txBody>
@@ -23106,7 +23273,7 @@
                 <a:ea typeface="Meiryo" pitchFamily="34" charset="-122"/>
                 <a:cs typeface="Meiryo" pitchFamily="34" charset="-120"/>
               </a:rPr>
-              <a:t>20</a:t>
+              <a:t>22</a:t>
             </a:r>
             <a:endParaRPr lang="en-US" sz="900" dirty="0"/>
           </a:p>
@@ -23735,7 +23902,7 @@
                 <a:ea typeface="Meiryo" pitchFamily="34" charset="-122"/>
                 <a:cs typeface="Meiryo" pitchFamily="34" charset="-120"/>
               </a:rPr>
-              <a:t>21</a:t>
+              <a:t>23</a:t>
             </a:r>
             <a:endParaRPr lang="en-US" sz="900" dirty="0"/>
           </a:p>
@@ -24859,7 +25026,7 @@
                 <a:ea typeface="Meiryo" pitchFamily="34" charset="-122"/>
                 <a:cs typeface="Meiryo" pitchFamily="34" charset="-120"/>
               </a:rPr>
-              <a:t>22</a:t>
+              <a:t>24</a:t>
             </a:r>
             <a:endParaRPr lang="en-US" sz="900" dirty="0"/>
           </a:p>
@@ -25910,7 +26077,7 @@
                 <a:ea typeface="Meiryo" pitchFamily="34" charset="-122"/>
                 <a:cs typeface="Meiryo" pitchFamily="34" charset="-120"/>
               </a:rPr>
-              <a:t>23</a:t>
+              <a:t>25</a:t>
             </a:r>
             <a:endParaRPr lang="en-US" sz="900" dirty="0"/>
           </a:p>
@@ -26917,6 +27084,2830 @@
               <a:t>会社の収支改善と、現場の無理のない運営の両立へ ― ご協力をお願いします。</a:t>
             </a:r>
             <a:endParaRPr lang="en-US" sz="1400" dirty="0"/>
+          </a:p>
+        </p:txBody>
+      </p:sp>
+    </p:spTree>
+  </p:cSld>
+  <p:clrMapOvr>
+    <a:masterClrMapping/>
+  </p:clrMapOvr>
+</p:sld>
+</file>
+
+<file path=ppt/slides/slide27.xml><?xml version="1.0" encoding="utf-8"?>
+<p:sld xmlns:a="http://schemas.openxmlformats.org/drawingml/2006/main" xmlns:p="http://schemas.openxmlformats.org/presentationml/2006/main" xmlns:r="http://schemas.openxmlformats.org/officeDocument/2006/relationships">
+  <p:cSld>
+    <p:spTree>
+      <p:nvGrpSpPr>
+        <p:cNvPr id="1" name=""/>
+        <p:cNvGrpSpPr/>
+        <p:nvPr/>
+      </p:nvGrpSpPr>
+      <p:grpSpPr/>
+      <p:sp>
+        <p:nvSpPr>
+          <p:cNvPr id="2" name="Rectangle 1"/>
+          <p:cNvSpPr/>
+          <p:nvPr/>
+        </p:nvSpPr>
+        <p:spPr>
+          <a:xfrm>
+            <a:off x="548640" y="502920"/>
+            <a:ext cx="10789920" cy="320040"/>
+          </a:xfrm>
+          <a:prstGeom prst="rect">
+            <a:avLst/>
+          </a:prstGeom>
+          <a:noFill/>
+          <a:ln>
+            <a:noFill/>
+          </a:ln>
+          <a:effectLst/>
+        </p:spPr>
+        <p:style>
+          <a:lnRef idx="1">
+            <a:schemeClr val="accent1"/>
+          </a:lnRef>
+          <a:fillRef idx="3">
+            <a:schemeClr val="accent1"/>
+          </a:fillRef>
+          <a:effectRef idx="2">
+            <a:schemeClr val="accent1"/>
+          </a:effectRef>
+          <a:fontRef idx="minor">
+            <a:schemeClr val="lt1"/>
+          </a:fontRef>
+        </p:style>
+        <p:txBody>
+          <a:bodyPr rtlCol="0" anchor="t" wrap="square" lIns="73152" rIns="73152" tIns="27432" bIns="27432"/>
+          <a:lstStyle/>
+          <a:p>
+            <a:pPr algn="l">
+              <a:spcBef>
+                <a:spcPts val="0"/>
+              </a:spcBef>
+              <a:spcAft>
+                <a:spcPts val="200"/>
+              </a:spcAft>
+            </a:pPr>
+            <a:r>
+              <a:rPr sz="1300" b="1">
+                <a:solidFill>
+                  <a:srgbClr val="2E5AAC"/>
+                </a:solidFill>
+                <a:latin typeface="Meiryo"/>
+              </a:rPr>
+              <a:t>現場での活用｜短時間シフトの設計</a:t>
+            </a:r>
+          </a:p>
+        </p:txBody>
+      </p:sp>
+      <p:sp>
+        <p:nvSpPr>
+          <p:cNvPr id="3" name="Rectangle 2"/>
+          <p:cNvSpPr/>
+          <p:nvPr/>
+        </p:nvSpPr>
+        <p:spPr>
+          <a:xfrm>
+            <a:off x="548640" y="841248"/>
+            <a:ext cx="11064240" cy="914400"/>
+          </a:xfrm>
+          <a:prstGeom prst="rect">
+            <a:avLst/>
+          </a:prstGeom>
+          <a:noFill/>
+          <a:ln>
+            <a:noFill/>
+          </a:ln>
+          <a:effectLst/>
+        </p:spPr>
+        <p:style>
+          <a:lnRef idx="1">
+            <a:schemeClr val="accent1"/>
+          </a:lnRef>
+          <a:fillRef idx="3">
+            <a:schemeClr val="accent1"/>
+          </a:fillRef>
+          <a:effectRef idx="2">
+            <a:schemeClr val="accent1"/>
+          </a:effectRef>
+          <a:fontRef idx="minor">
+            <a:schemeClr val="lt1"/>
+          </a:fontRef>
+        </p:style>
+        <p:txBody>
+          <a:bodyPr rtlCol="0" anchor="t" wrap="square" lIns="73152" rIns="73152" tIns="27432" bIns="27432"/>
+          <a:lstStyle/>
+          <a:p>
+            <a:pPr algn="l">
+              <a:spcBef>
+                <a:spcPts val="0"/>
+              </a:spcBef>
+              <a:spcAft>
+                <a:spcPts val="200"/>
+              </a:spcAft>
+            </a:pPr>
+            <a:r>
+              <a:rPr sz="3000" b="1">
+                <a:solidFill>
+                  <a:srgbClr val="1B2A4A"/>
+                </a:solidFill>
+                <a:latin typeface="Meiryo"/>
+              </a:rPr>
+              <a:t>朝の山を「早番・中番」の2本で受ける</a:t>
+            </a:r>
+          </a:p>
+        </p:txBody>
+      </p:sp>
+      <p:sp>
+        <p:nvSpPr>
+          <p:cNvPr id="4" name="Rounded Rectangle 3"/>
+          <p:cNvSpPr/>
+          <p:nvPr/>
+        </p:nvSpPr>
+        <p:spPr>
+          <a:xfrm>
+            <a:off x="548640" y="1920240"/>
+            <a:ext cx="5486400" cy="1024128"/>
+          </a:xfrm>
+          <a:prstGeom prst="roundRect">
+            <a:avLst/>
+          </a:prstGeom>
+          <a:solidFill>
+            <a:srgbClr val="2E5AAC"/>
+          </a:solidFill>
+          <a:ln>
+            <a:noFill/>
+          </a:ln>
+          <a:effectLst/>
+        </p:spPr>
+        <p:style>
+          <a:lnRef idx="1">
+            <a:schemeClr val="accent1"/>
+          </a:lnRef>
+          <a:fillRef idx="3">
+            <a:schemeClr val="accent1"/>
+          </a:fillRef>
+          <a:effectRef idx="2">
+            <a:schemeClr val="accent1"/>
+          </a:effectRef>
+          <a:fontRef idx="minor">
+            <a:schemeClr val="lt1"/>
+          </a:fontRef>
+        </p:style>
+        <p:txBody>
+          <a:bodyPr rtlCol="0" anchor="ctr" wrap="square" lIns="73152" rIns="73152" tIns="27432" bIns="27432"/>
+          <a:lstStyle/>
+          <a:p>
+            <a:pPr algn="l">
+              <a:spcBef>
+                <a:spcPts val="0"/>
+              </a:spcBef>
+              <a:spcAft>
+                <a:spcPts val="200"/>
+              </a:spcAft>
+            </a:pPr>
+            <a:r>
+              <a:rPr sz="1500" b="1">
+                <a:solidFill>
+                  <a:srgbClr val="FFFFFF"/>
+                </a:solidFill>
+                <a:latin typeface="Meiryo"/>
+              </a:rPr>
+              <a:t>早番A　05:45 – 10:15（4.5h）</a:t>
+            </a:r>
+          </a:p>
+          <a:p>
+            <a:pPr algn="l">
+              <a:spcBef>
+                <a:spcPts val="0"/>
+              </a:spcBef>
+              <a:spcAft>
+                <a:spcPts val="200"/>
+              </a:spcAft>
+            </a:pPr>
+            <a:r>
+              <a:rPr sz="1500" b="1">
+                <a:solidFill>
+                  <a:srgbClr val="FFFFFF"/>
+                </a:solidFill>
+                <a:latin typeface="Meiryo"/>
+              </a:rPr>
+              <a:t>開設波（カウンター開設）＋到着ピーク前半</a:t>
+            </a:r>
+          </a:p>
+        </p:txBody>
+      </p:sp>
+      <p:sp>
+        <p:nvSpPr>
+          <p:cNvPr id="5" name="Rounded Rectangle 4"/>
+          <p:cNvSpPr/>
+          <p:nvPr/>
+        </p:nvSpPr>
+        <p:spPr>
+          <a:xfrm>
+            <a:off x="6172200" y="1920240"/>
+            <a:ext cx="5486400" cy="1024128"/>
+          </a:xfrm>
+          <a:prstGeom prst="roundRect">
+            <a:avLst/>
+          </a:prstGeom>
+          <a:solidFill>
+            <a:srgbClr val="2C6E49"/>
+          </a:solidFill>
+          <a:ln>
+            <a:noFill/>
+          </a:ln>
+          <a:effectLst/>
+        </p:spPr>
+        <p:style>
+          <a:lnRef idx="1">
+            <a:schemeClr val="accent1"/>
+          </a:lnRef>
+          <a:fillRef idx="3">
+            <a:schemeClr val="accent1"/>
+          </a:fillRef>
+          <a:effectRef idx="2">
+            <a:schemeClr val="accent1"/>
+          </a:effectRef>
+          <a:fontRef idx="minor">
+            <a:schemeClr val="lt1"/>
+          </a:fontRef>
+        </p:style>
+        <p:txBody>
+          <a:bodyPr rtlCol="0" anchor="ctr" wrap="square" lIns="73152" rIns="73152" tIns="27432" bIns="27432"/>
+          <a:lstStyle/>
+          <a:p>
+            <a:pPr algn="l">
+              <a:spcBef>
+                <a:spcPts val="0"/>
+              </a:spcBef>
+              <a:spcAft>
+                <a:spcPts val="200"/>
+              </a:spcAft>
+            </a:pPr>
+            <a:r>
+              <a:rPr sz="1500" b="1">
+                <a:solidFill>
+                  <a:srgbClr val="FFFFFF"/>
+                </a:solidFill>
+                <a:latin typeface="Meiryo"/>
+              </a:rPr>
+              <a:t>中番B　07:30 – 12:00（4.5h）</a:t>
+            </a:r>
+          </a:p>
+          <a:p>
+            <a:pPr algn="l">
+              <a:spcBef>
+                <a:spcPts val="0"/>
+              </a:spcBef>
+              <a:spcAft>
+                <a:spcPts val="200"/>
+              </a:spcAft>
+            </a:pPr>
+            <a:r>
+              <a:rPr sz="1500" b="1">
+                <a:solidFill>
+                  <a:srgbClr val="FFFFFF"/>
+                </a:solidFill>
+                <a:latin typeface="Meiryo"/>
+              </a:rPr>
+              <a:t>到着ピーク＋10:30以降の後半出発</a:t>
+            </a:r>
+          </a:p>
+        </p:txBody>
+      </p:sp>
+      <p:sp>
+        <p:nvSpPr>
+          <p:cNvPr id="6" name="Rectangle 5"/>
+          <p:cNvSpPr/>
+          <p:nvPr/>
+        </p:nvSpPr>
+        <p:spPr>
+          <a:xfrm>
+            <a:off x="1234440" y="3611880"/>
+            <a:ext cx="9144" cy="1737360"/>
+          </a:xfrm>
+          <a:prstGeom prst="rect">
+            <a:avLst/>
+          </a:prstGeom>
+          <a:solidFill>
+            <a:srgbClr val="D9DFEA"/>
+          </a:solidFill>
+          <a:ln>
+            <a:noFill/>
+          </a:ln>
+          <a:effectLst/>
+        </p:spPr>
+        <p:style>
+          <a:lnRef idx="1">
+            <a:schemeClr val="accent1"/>
+          </a:lnRef>
+          <a:fillRef idx="3">
+            <a:schemeClr val="accent1"/>
+          </a:fillRef>
+          <a:effectRef idx="2">
+            <a:schemeClr val="accent1"/>
+          </a:effectRef>
+          <a:fontRef idx="minor">
+            <a:schemeClr val="lt1"/>
+          </a:fontRef>
+        </p:style>
+        <p:txBody>
+          <a:bodyPr rtlCol="0" anchor="t" wrap="square" lIns="73152" rIns="73152" tIns="27432" bIns="27432"/>
+          <a:lstStyle/>
+          <a:p>
+            <a:pPr algn="ctr"/>
+          </a:p>
+        </p:txBody>
+      </p:sp>
+      <p:sp>
+        <p:nvSpPr>
+          <p:cNvPr id="7" name="Rectangle 6"/>
+          <p:cNvSpPr/>
+          <p:nvPr/>
+        </p:nvSpPr>
+        <p:spPr>
+          <a:xfrm>
+            <a:off x="1005840" y="3364992"/>
+            <a:ext cx="457200" cy="228600"/>
+          </a:xfrm>
+          <a:prstGeom prst="rect">
+            <a:avLst/>
+          </a:prstGeom>
+          <a:noFill/>
+          <a:ln>
+            <a:noFill/>
+          </a:ln>
+          <a:effectLst/>
+        </p:spPr>
+        <p:style>
+          <a:lnRef idx="1">
+            <a:schemeClr val="accent1"/>
+          </a:lnRef>
+          <a:fillRef idx="3">
+            <a:schemeClr val="accent1"/>
+          </a:fillRef>
+          <a:effectRef idx="2">
+            <a:schemeClr val="accent1"/>
+          </a:effectRef>
+          <a:fontRef idx="minor">
+            <a:schemeClr val="lt1"/>
+          </a:fontRef>
+        </p:style>
+        <p:txBody>
+          <a:bodyPr rtlCol="0" anchor="t" wrap="square" lIns="73152" rIns="73152" tIns="27432" bIns="27432"/>
+          <a:lstStyle/>
+          <a:p>
+            <a:pPr algn="ctr">
+              <a:spcBef>
+                <a:spcPts val="0"/>
+              </a:spcBef>
+              <a:spcAft>
+                <a:spcPts val="200"/>
+              </a:spcAft>
+            </a:pPr>
+            <a:r>
+              <a:rPr sz="900" b="0">
+                <a:solidFill>
+                  <a:srgbClr val="6B7686"/>
+                </a:solidFill>
+                <a:latin typeface="Meiryo"/>
+              </a:rPr>
+              <a:t>5</a:t>
+            </a:r>
+          </a:p>
+        </p:txBody>
+      </p:sp>
+      <p:sp>
+        <p:nvSpPr>
+          <p:cNvPr id="8" name="Rectangle 7"/>
+          <p:cNvSpPr/>
+          <p:nvPr/>
+        </p:nvSpPr>
+        <p:spPr>
+          <a:xfrm>
+            <a:off x="2697480" y="3611880"/>
+            <a:ext cx="9144" cy="1737360"/>
+          </a:xfrm>
+          <a:prstGeom prst="rect">
+            <a:avLst/>
+          </a:prstGeom>
+          <a:solidFill>
+            <a:srgbClr val="D9DFEA"/>
+          </a:solidFill>
+          <a:ln>
+            <a:noFill/>
+          </a:ln>
+          <a:effectLst/>
+        </p:spPr>
+        <p:style>
+          <a:lnRef idx="1">
+            <a:schemeClr val="accent1"/>
+          </a:lnRef>
+          <a:fillRef idx="3">
+            <a:schemeClr val="accent1"/>
+          </a:fillRef>
+          <a:effectRef idx="2">
+            <a:schemeClr val="accent1"/>
+          </a:effectRef>
+          <a:fontRef idx="minor">
+            <a:schemeClr val="lt1"/>
+          </a:fontRef>
+        </p:style>
+        <p:txBody>
+          <a:bodyPr rtlCol="0" anchor="t" wrap="square" lIns="73152" rIns="73152" tIns="27432" bIns="27432"/>
+          <a:lstStyle/>
+          <a:p>
+            <a:pPr algn="ctr"/>
+          </a:p>
+        </p:txBody>
+      </p:sp>
+      <p:sp>
+        <p:nvSpPr>
+          <p:cNvPr id="9" name="Rectangle 8"/>
+          <p:cNvSpPr/>
+          <p:nvPr/>
+        </p:nvSpPr>
+        <p:spPr>
+          <a:xfrm>
+            <a:off x="2468880" y="3364992"/>
+            <a:ext cx="457200" cy="228600"/>
+          </a:xfrm>
+          <a:prstGeom prst="rect">
+            <a:avLst/>
+          </a:prstGeom>
+          <a:noFill/>
+          <a:ln>
+            <a:noFill/>
+          </a:ln>
+          <a:effectLst/>
+        </p:spPr>
+        <p:style>
+          <a:lnRef idx="1">
+            <a:schemeClr val="accent1"/>
+          </a:lnRef>
+          <a:fillRef idx="3">
+            <a:schemeClr val="accent1"/>
+          </a:fillRef>
+          <a:effectRef idx="2">
+            <a:schemeClr val="accent1"/>
+          </a:effectRef>
+          <a:fontRef idx="minor">
+            <a:schemeClr val="lt1"/>
+          </a:fontRef>
+        </p:style>
+        <p:txBody>
+          <a:bodyPr rtlCol="0" anchor="t" wrap="square" lIns="73152" rIns="73152" tIns="27432" bIns="27432"/>
+          <a:lstStyle/>
+          <a:p>
+            <a:pPr algn="ctr">
+              <a:spcBef>
+                <a:spcPts val="0"/>
+              </a:spcBef>
+              <a:spcAft>
+                <a:spcPts val="200"/>
+              </a:spcAft>
+            </a:pPr>
+            <a:r>
+              <a:rPr sz="900" b="0">
+                <a:solidFill>
+                  <a:srgbClr val="6B7686"/>
+                </a:solidFill>
+                <a:latin typeface="Meiryo"/>
+              </a:rPr>
+              <a:t>6</a:t>
+            </a:r>
+          </a:p>
+        </p:txBody>
+      </p:sp>
+      <p:sp>
+        <p:nvSpPr>
+          <p:cNvPr id="10" name="Rectangle 9"/>
+          <p:cNvSpPr/>
+          <p:nvPr/>
+        </p:nvSpPr>
+        <p:spPr>
+          <a:xfrm>
+            <a:off x="4160520" y="3611880"/>
+            <a:ext cx="9144" cy="1737360"/>
+          </a:xfrm>
+          <a:prstGeom prst="rect">
+            <a:avLst/>
+          </a:prstGeom>
+          <a:solidFill>
+            <a:srgbClr val="D9DFEA"/>
+          </a:solidFill>
+          <a:ln>
+            <a:noFill/>
+          </a:ln>
+          <a:effectLst/>
+        </p:spPr>
+        <p:style>
+          <a:lnRef idx="1">
+            <a:schemeClr val="accent1"/>
+          </a:lnRef>
+          <a:fillRef idx="3">
+            <a:schemeClr val="accent1"/>
+          </a:fillRef>
+          <a:effectRef idx="2">
+            <a:schemeClr val="accent1"/>
+          </a:effectRef>
+          <a:fontRef idx="minor">
+            <a:schemeClr val="lt1"/>
+          </a:fontRef>
+        </p:style>
+        <p:txBody>
+          <a:bodyPr rtlCol="0" anchor="t" wrap="square" lIns="73152" rIns="73152" tIns="27432" bIns="27432"/>
+          <a:lstStyle/>
+          <a:p>
+            <a:pPr algn="ctr"/>
+          </a:p>
+        </p:txBody>
+      </p:sp>
+      <p:sp>
+        <p:nvSpPr>
+          <p:cNvPr id="11" name="Rectangle 10"/>
+          <p:cNvSpPr/>
+          <p:nvPr/>
+        </p:nvSpPr>
+        <p:spPr>
+          <a:xfrm>
+            <a:off x="3931920" y="3364992"/>
+            <a:ext cx="457200" cy="228600"/>
+          </a:xfrm>
+          <a:prstGeom prst="rect">
+            <a:avLst/>
+          </a:prstGeom>
+          <a:noFill/>
+          <a:ln>
+            <a:noFill/>
+          </a:ln>
+          <a:effectLst/>
+        </p:spPr>
+        <p:style>
+          <a:lnRef idx="1">
+            <a:schemeClr val="accent1"/>
+          </a:lnRef>
+          <a:fillRef idx="3">
+            <a:schemeClr val="accent1"/>
+          </a:fillRef>
+          <a:effectRef idx="2">
+            <a:schemeClr val="accent1"/>
+          </a:effectRef>
+          <a:fontRef idx="minor">
+            <a:schemeClr val="lt1"/>
+          </a:fontRef>
+        </p:style>
+        <p:txBody>
+          <a:bodyPr rtlCol="0" anchor="t" wrap="square" lIns="73152" rIns="73152" tIns="27432" bIns="27432"/>
+          <a:lstStyle/>
+          <a:p>
+            <a:pPr algn="ctr">
+              <a:spcBef>
+                <a:spcPts val="0"/>
+              </a:spcBef>
+              <a:spcAft>
+                <a:spcPts val="200"/>
+              </a:spcAft>
+            </a:pPr>
+            <a:r>
+              <a:rPr sz="900" b="0">
+                <a:solidFill>
+                  <a:srgbClr val="6B7686"/>
+                </a:solidFill>
+                <a:latin typeface="Meiryo"/>
+              </a:rPr>
+              <a:t>7</a:t>
+            </a:r>
+          </a:p>
+        </p:txBody>
+      </p:sp>
+      <p:sp>
+        <p:nvSpPr>
+          <p:cNvPr id="12" name="Rectangle 11"/>
+          <p:cNvSpPr/>
+          <p:nvPr/>
+        </p:nvSpPr>
+        <p:spPr>
+          <a:xfrm>
+            <a:off x="5623560" y="3611880"/>
+            <a:ext cx="9144" cy="1737360"/>
+          </a:xfrm>
+          <a:prstGeom prst="rect">
+            <a:avLst/>
+          </a:prstGeom>
+          <a:solidFill>
+            <a:srgbClr val="D9DFEA"/>
+          </a:solidFill>
+          <a:ln>
+            <a:noFill/>
+          </a:ln>
+          <a:effectLst/>
+        </p:spPr>
+        <p:style>
+          <a:lnRef idx="1">
+            <a:schemeClr val="accent1"/>
+          </a:lnRef>
+          <a:fillRef idx="3">
+            <a:schemeClr val="accent1"/>
+          </a:fillRef>
+          <a:effectRef idx="2">
+            <a:schemeClr val="accent1"/>
+          </a:effectRef>
+          <a:fontRef idx="minor">
+            <a:schemeClr val="lt1"/>
+          </a:fontRef>
+        </p:style>
+        <p:txBody>
+          <a:bodyPr rtlCol="0" anchor="t" wrap="square" lIns="73152" rIns="73152" tIns="27432" bIns="27432"/>
+          <a:lstStyle/>
+          <a:p>
+            <a:pPr algn="ctr"/>
+          </a:p>
+        </p:txBody>
+      </p:sp>
+      <p:sp>
+        <p:nvSpPr>
+          <p:cNvPr id="13" name="Rectangle 12"/>
+          <p:cNvSpPr/>
+          <p:nvPr/>
+        </p:nvSpPr>
+        <p:spPr>
+          <a:xfrm>
+            <a:off x="5394960" y="3364992"/>
+            <a:ext cx="457200" cy="228600"/>
+          </a:xfrm>
+          <a:prstGeom prst="rect">
+            <a:avLst/>
+          </a:prstGeom>
+          <a:noFill/>
+          <a:ln>
+            <a:noFill/>
+          </a:ln>
+          <a:effectLst/>
+        </p:spPr>
+        <p:style>
+          <a:lnRef idx="1">
+            <a:schemeClr val="accent1"/>
+          </a:lnRef>
+          <a:fillRef idx="3">
+            <a:schemeClr val="accent1"/>
+          </a:fillRef>
+          <a:effectRef idx="2">
+            <a:schemeClr val="accent1"/>
+          </a:effectRef>
+          <a:fontRef idx="minor">
+            <a:schemeClr val="lt1"/>
+          </a:fontRef>
+        </p:style>
+        <p:txBody>
+          <a:bodyPr rtlCol="0" anchor="t" wrap="square" lIns="73152" rIns="73152" tIns="27432" bIns="27432"/>
+          <a:lstStyle/>
+          <a:p>
+            <a:pPr algn="ctr">
+              <a:spcBef>
+                <a:spcPts val="0"/>
+              </a:spcBef>
+              <a:spcAft>
+                <a:spcPts val="200"/>
+              </a:spcAft>
+            </a:pPr>
+            <a:r>
+              <a:rPr sz="900" b="0">
+                <a:solidFill>
+                  <a:srgbClr val="6B7686"/>
+                </a:solidFill>
+                <a:latin typeface="Meiryo"/>
+              </a:rPr>
+              <a:t>8</a:t>
+            </a:r>
+          </a:p>
+        </p:txBody>
+      </p:sp>
+      <p:sp>
+        <p:nvSpPr>
+          <p:cNvPr id="14" name="Rectangle 13"/>
+          <p:cNvSpPr/>
+          <p:nvPr/>
+        </p:nvSpPr>
+        <p:spPr>
+          <a:xfrm>
+            <a:off x="7086600" y="3611880"/>
+            <a:ext cx="9144" cy="1737360"/>
+          </a:xfrm>
+          <a:prstGeom prst="rect">
+            <a:avLst/>
+          </a:prstGeom>
+          <a:solidFill>
+            <a:srgbClr val="D9DFEA"/>
+          </a:solidFill>
+          <a:ln>
+            <a:noFill/>
+          </a:ln>
+          <a:effectLst/>
+        </p:spPr>
+        <p:style>
+          <a:lnRef idx="1">
+            <a:schemeClr val="accent1"/>
+          </a:lnRef>
+          <a:fillRef idx="3">
+            <a:schemeClr val="accent1"/>
+          </a:fillRef>
+          <a:effectRef idx="2">
+            <a:schemeClr val="accent1"/>
+          </a:effectRef>
+          <a:fontRef idx="minor">
+            <a:schemeClr val="lt1"/>
+          </a:fontRef>
+        </p:style>
+        <p:txBody>
+          <a:bodyPr rtlCol="0" anchor="t" wrap="square" lIns="73152" rIns="73152" tIns="27432" bIns="27432"/>
+          <a:lstStyle/>
+          <a:p>
+            <a:pPr algn="ctr"/>
+          </a:p>
+        </p:txBody>
+      </p:sp>
+      <p:sp>
+        <p:nvSpPr>
+          <p:cNvPr id="15" name="Rectangle 14"/>
+          <p:cNvSpPr/>
+          <p:nvPr/>
+        </p:nvSpPr>
+        <p:spPr>
+          <a:xfrm>
+            <a:off x="6858000" y="3364992"/>
+            <a:ext cx="457200" cy="228600"/>
+          </a:xfrm>
+          <a:prstGeom prst="rect">
+            <a:avLst/>
+          </a:prstGeom>
+          <a:noFill/>
+          <a:ln>
+            <a:noFill/>
+          </a:ln>
+          <a:effectLst/>
+        </p:spPr>
+        <p:style>
+          <a:lnRef idx="1">
+            <a:schemeClr val="accent1"/>
+          </a:lnRef>
+          <a:fillRef idx="3">
+            <a:schemeClr val="accent1"/>
+          </a:fillRef>
+          <a:effectRef idx="2">
+            <a:schemeClr val="accent1"/>
+          </a:effectRef>
+          <a:fontRef idx="minor">
+            <a:schemeClr val="lt1"/>
+          </a:fontRef>
+        </p:style>
+        <p:txBody>
+          <a:bodyPr rtlCol="0" anchor="t" wrap="square" lIns="73152" rIns="73152" tIns="27432" bIns="27432"/>
+          <a:lstStyle/>
+          <a:p>
+            <a:pPr algn="ctr">
+              <a:spcBef>
+                <a:spcPts val="0"/>
+              </a:spcBef>
+              <a:spcAft>
+                <a:spcPts val="200"/>
+              </a:spcAft>
+            </a:pPr>
+            <a:r>
+              <a:rPr sz="900" b="0">
+                <a:solidFill>
+                  <a:srgbClr val="6B7686"/>
+                </a:solidFill>
+                <a:latin typeface="Meiryo"/>
+              </a:rPr>
+              <a:t>9</a:t>
+            </a:r>
+          </a:p>
+        </p:txBody>
+      </p:sp>
+      <p:sp>
+        <p:nvSpPr>
+          <p:cNvPr id="16" name="Rectangle 15"/>
+          <p:cNvSpPr/>
+          <p:nvPr/>
+        </p:nvSpPr>
+        <p:spPr>
+          <a:xfrm>
+            <a:off x="8549640" y="3611880"/>
+            <a:ext cx="9144" cy="1737360"/>
+          </a:xfrm>
+          <a:prstGeom prst="rect">
+            <a:avLst/>
+          </a:prstGeom>
+          <a:solidFill>
+            <a:srgbClr val="D9DFEA"/>
+          </a:solidFill>
+          <a:ln>
+            <a:noFill/>
+          </a:ln>
+          <a:effectLst/>
+        </p:spPr>
+        <p:style>
+          <a:lnRef idx="1">
+            <a:schemeClr val="accent1"/>
+          </a:lnRef>
+          <a:fillRef idx="3">
+            <a:schemeClr val="accent1"/>
+          </a:fillRef>
+          <a:effectRef idx="2">
+            <a:schemeClr val="accent1"/>
+          </a:effectRef>
+          <a:fontRef idx="minor">
+            <a:schemeClr val="lt1"/>
+          </a:fontRef>
+        </p:style>
+        <p:txBody>
+          <a:bodyPr rtlCol="0" anchor="t" wrap="square" lIns="73152" rIns="73152" tIns="27432" bIns="27432"/>
+          <a:lstStyle/>
+          <a:p>
+            <a:pPr algn="ctr"/>
+          </a:p>
+        </p:txBody>
+      </p:sp>
+      <p:sp>
+        <p:nvSpPr>
+          <p:cNvPr id="17" name="Rectangle 16"/>
+          <p:cNvSpPr/>
+          <p:nvPr/>
+        </p:nvSpPr>
+        <p:spPr>
+          <a:xfrm>
+            <a:off x="8321040" y="3364992"/>
+            <a:ext cx="457200" cy="228600"/>
+          </a:xfrm>
+          <a:prstGeom prst="rect">
+            <a:avLst/>
+          </a:prstGeom>
+          <a:noFill/>
+          <a:ln>
+            <a:noFill/>
+          </a:ln>
+          <a:effectLst/>
+        </p:spPr>
+        <p:style>
+          <a:lnRef idx="1">
+            <a:schemeClr val="accent1"/>
+          </a:lnRef>
+          <a:fillRef idx="3">
+            <a:schemeClr val="accent1"/>
+          </a:fillRef>
+          <a:effectRef idx="2">
+            <a:schemeClr val="accent1"/>
+          </a:effectRef>
+          <a:fontRef idx="minor">
+            <a:schemeClr val="lt1"/>
+          </a:fontRef>
+        </p:style>
+        <p:txBody>
+          <a:bodyPr rtlCol="0" anchor="t" wrap="square" lIns="73152" rIns="73152" tIns="27432" bIns="27432"/>
+          <a:lstStyle/>
+          <a:p>
+            <a:pPr algn="ctr">
+              <a:spcBef>
+                <a:spcPts val="0"/>
+              </a:spcBef>
+              <a:spcAft>
+                <a:spcPts val="200"/>
+              </a:spcAft>
+            </a:pPr>
+            <a:r>
+              <a:rPr sz="900" b="0">
+                <a:solidFill>
+                  <a:srgbClr val="6B7686"/>
+                </a:solidFill>
+                <a:latin typeface="Meiryo"/>
+              </a:rPr>
+              <a:t>10</a:t>
+            </a:r>
+          </a:p>
+        </p:txBody>
+      </p:sp>
+      <p:sp>
+        <p:nvSpPr>
+          <p:cNvPr id="18" name="Rectangle 17"/>
+          <p:cNvSpPr/>
+          <p:nvPr/>
+        </p:nvSpPr>
+        <p:spPr>
+          <a:xfrm>
+            <a:off x="10012680" y="3611880"/>
+            <a:ext cx="9144" cy="1737360"/>
+          </a:xfrm>
+          <a:prstGeom prst="rect">
+            <a:avLst/>
+          </a:prstGeom>
+          <a:solidFill>
+            <a:srgbClr val="D9DFEA"/>
+          </a:solidFill>
+          <a:ln>
+            <a:noFill/>
+          </a:ln>
+          <a:effectLst/>
+        </p:spPr>
+        <p:style>
+          <a:lnRef idx="1">
+            <a:schemeClr val="accent1"/>
+          </a:lnRef>
+          <a:fillRef idx="3">
+            <a:schemeClr val="accent1"/>
+          </a:fillRef>
+          <a:effectRef idx="2">
+            <a:schemeClr val="accent1"/>
+          </a:effectRef>
+          <a:fontRef idx="minor">
+            <a:schemeClr val="lt1"/>
+          </a:fontRef>
+        </p:style>
+        <p:txBody>
+          <a:bodyPr rtlCol="0" anchor="t" wrap="square" lIns="73152" rIns="73152" tIns="27432" bIns="27432"/>
+          <a:lstStyle/>
+          <a:p>
+            <a:pPr algn="ctr"/>
+          </a:p>
+        </p:txBody>
+      </p:sp>
+      <p:sp>
+        <p:nvSpPr>
+          <p:cNvPr id="19" name="Rectangle 18"/>
+          <p:cNvSpPr/>
+          <p:nvPr/>
+        </p:nvSpPr>
+        <p:spPr>
+          <a:xfrm>
+            <a:off x="9784080" y="3364992"/>
+            <a:ext cx="457200" cy="228600"/>
+          </a:xfrm>
+          <a:prstGeom prst="rect">
+            <a:avLst/>
+          </a:prstGeom>
+          <a:noFill/>
+          <a:ln>
+            <a:noFill/>
+          </a:ln>
+          <a:effectLst/>
+        </p:spPr>
+        <p:style>
+          <a:lnRef idx="1">
+            <a:schemeClr val="accent1"/>
+          </a:lnRef>
+          <a:fillRef idx="3">
+            <a:schemeClr val="accent1"/>
+          </a:fillRef>
+          <a:effectRef idx="2">
+            <a:schemeClr val="accent1"/>
+          </a:effectRef>
+          <a:fontRef idx="minor">
+            <a:schemeClr val="lt1"/>
+          </a:fontRef>
+        </p:style>
+        <p:txBody>
+          <a:bodyPr rtlCol="0" anchor="t" wrap="square" lIns="73152" rIns="73152" tIns="27432" bIns="27432"/>
+          <a:lstStyle/>
+          <a:p>
+            <a:pPr algn="ctr">
+              <a:spcBef>
+                <a:spcPts val="0"/>
+              </a:spcBef>
+              <a:spcAft>
+                <a:spcPts val="200"/>
+              </a:spcAft>
+            </a:pPr>
+            <a:r>
+              <a:rPr sz="900" b="0">
+                <a:solidFill>
+                  <a:srgbClr val="6B7686"/>
+                </a:solidFill>
+                <a:latin typeface="Meiryo"/>
+              </a:rPr>
+              <a:t>11</a:t>
+            </a:r>
+          </a:p>
+        </p:txBody>
+      </p:sp>
+      <p:sp>
+        <p:nvSpPr>
+          <p:cNvPr id="20" name="Rectangle 19"/>
+          <p:cNvSpPr/>
+          <p:nvPr/>
+        </p:nvSpPr>
+        <p:spPr>
+          <a:xfrm>
+            <a:off x="11475720" y="3611880"/>
+            <a:ext cx="9144" cy="1737360"/>
+          </a:xfrm>
+          <a:prstGeom prst="rect">
+            <a:avLst/>
+          </a:prstGeom>
+          <a:solidFill>
+            <a:srgbClr val="D9DFEA"/>
+          </a:solidFill>
+          <a:ln>
+            <a:noFill/>
+          </a:ln>
+          <a:effectLst/>
+        </p:spPr>
+        <p:style>
+          <a:lnRef idx="1">
+            <a:schemeClr val="accent1"/>
+          </a:lnRef>
+          <a:fillRef idx="3">
+            <a:schemeClr val="accent1"/>
+          </a:fillRef>
+          <a:effectRef idx="2">
+            <a:schemeClr val="accent1"/>
+          </a:effectRef>
+          <a:fontRef idx="minor">
+            <a:schemeClr val="lt1"/>
+          </a:fontRef>
+        </p:style>
+        <p:txBody>
+          <a:bodyPr rtlCol="0" anchor="t" wrap="square" lIns="73152" rIns="73152" tIns="27432" bIns="27432"/>
+          <a:lstStyle/>
+          <a:p>
+            <a:pPr algn="ctr"/>
+          </a:p>
+        </p:txBody>
+      </p:sp>
+      <p:sp>
+        <p:nvSpPr>
+          <p:cNvPr id="21" name="Rectangle 20"/>
+          <p:cNvSpPr/>
+          <p:nvPr/>
+        </p:nvSpPr>
+        <p:spPr>
+          <a:xfrm>
+            <a:off x="11247120" y="3364992"/>
+            <a:ext cx="457200" cy="228600"/>
+          </a:xfrm>
+          <a:prstGeom prst="rect">
+            <a:avLst/>
+          </a:prstGeom>
+          <a:noFill/>
+          <a:ln>
+            <a:noFill/>
+          </a:ln>
+          <a:effectLst/>
+        </p:spPr>
+        <p:style>
+          <a:lnRef idx="1">
+            <a:schemeClr val="accent1"/>
+          </a:lnRef>
+          <a:fillRef idx="3">
+            <a:schemeClr val="accent1"/>
+          </a:fillRef>
+          <a:effectRef idx="2">
+            <a:schemeClr val="accent1"/>
+          </a:effectRef>
+          <a:fontRef idx="minor">
+            <a:schemeClr val="lt1"/>
+          </a:fontRef>
+        </p:style>
+        <p:txBody>
+          <a:bodyPr rtlCol="0" anchor="t" wrap="square" lIns="73152" rIns="73152" tIns="27432" bIns="27432"/>
+          <a:lstStyle/>
+          <a:p>
+            <a:pPr algn="ctr">
+              <a:spcBef>
+                <a:spcPts val="0"/>
+              </a:spcBef>
+              <a:spcAft>
+                <a:spcPts val="200"/>
+              </a:spcAft>
+            </a:pPr>
+            <a:r>
+              <a:rPr sz="900" b="0">
+                <a:solidFill>
+                  <a:srgbClr val="6B7686"/>
+                </a:solidFill>
+                <a:latin typeface="Meiryo"/>
+              </a:rPr>
+              <a:t>12</a:t>
+            </a:r>
+          </a:p>
+        </p:txBody>
+      </p:sp>
+      <p:sp>
+        <p:nvSpPr>
+          <p:cNvPr id="22" name="Rectangle 21"/>
+          <p:cNvSpPr/>
+          <p:nvPr/>
+        </p:nvSpPr>
+        <p:spPr>
+          <a:xfrm>
+            <a:off x="2568244" y="3611880"/>
+            <a:ext cx="14630" cy="1737360"/>
+          </a:xfrm>
+          <a:prstGeom prst="rect">
+            <a:avLst/>
+          </a:prstGeom>
+          <a:solidFill>
+            <a:srgbClr val="9AA6B8"/>
+          </a:solidFill>
+          <a:ln>
+            <a:noFill/>
+          </a:ln>
+          <a:effectLst/>
+        </p:spPr>
+        <p:style>
+          <a:lnRef idx="1">
+            <a:schemeClr val="accent1"/>
+          </a:lnRef>
+          <a:fillRef idx="3">
+            <a:schemeClr val="accent1"/>
+          </a:fillRef>
+          <a:effectRef idx="2">
+            <a:schemeClr val="accent1"/>
+          </a:effectRef>
+          <a:fontRef idx="minor">
+            <a:schemeClr val="lt1"/>
+          </a:fontRef>
+        </p:style>
+        <p:txBody>
+          <a:bodyPr rtlCol="0" anchor="t" wrap="square" lIns="73152" rIns="73152" tIns="27432" bIns="27432"/>
+          <a:lstStyle/>
+          <a:p>
+            <a:pPr algn="ctr"/>
+          </a:p>
+        </p:txBody>
+      </p:sp>
+      <p:sp>
+        <p:nvSpPr>
+          <p:cNvPr id="23" name="Rectangle 22"/>
+          <p:cNvSpPr/>
+          <p:nvPr/>
+        </p:nvSpPr>
+        <p:spPr>
+          <a:xfrm>
+            <a:off x="1661160" y="3611880"/>
+            <a:ext cx="1828800" cy="237744"/>
+          </a:xfrm>
+          <a:prstGeom prst="rect">
+            <a:avLst/>
+          </a:prstGeom>
+          <a:noFill/>
+          <a:ln>
+            <a:noFill/>
+          </a:ln>
+          <a:effectLst/>
+        </p:spPr>
+        <p:style>
+          <a:lnRef idx="1">
+            <a:schemeClr val="accent1"/>
+          </a:lnRef>
+          <a:fillRef idx="3">
+            <a:schemeClr val="accent1"/>
+          </a:fillRef>
+          <a:effectRef idx="2">
+            <a:schemeClr val="accent1"/>
+          </a:effectRef>
+          <a:fontRef idx="minor">
+            <a:schemeClr val="lt1"/>
+          </a:fontRef>
+        </p:style>
+        <p:txBody>
+          <a:bodyPr rtlCol="0" anchor="t" wrap="square" lIns="73152" rIns="73152" tIns="27432" bIns="27432"/>
+          <a:lstStyle/>
+          <a:p>
+            <a:pPr algn="ctr">
+              <a:spcBef>
+                <a:spcPts val="0"/>
+              </a:spcBef>
+              <a:spcAft>
+                <a:spcPts val="200"/>
+              </a:spcAft>
+            </a:pPr>
+            <a:r>
+              <a:rPr sz="900" b="1">
+                <a:solidFill>
+                  <a:srgbClr val="9AA6B8"/>
+                </a:solidFill>
+                <a:latin typeface="Meiryo"/>
+              </a:rPr>
+              <a:t>開設波 05:55</a:t>
+            </a:r>
+          </a:p>
+        </p:txBody>
+      </p:sp>
+      <p:sp>
+        <p:nvSpPr>
+          <p:cNvPr id="24" name="Rectangle 23"/>
+          <p:cNvSpPr/>
+          <p:nvPr/>
+        </p:nvSpPr>
+        <p:spPr>
+          <a:xfrm>
+            <a:off x="6347764" y="3611880"/>
+            <a:ext cx="14630" cy="1737360"/>
+          </a:xfrm>
+          <a:prstGeom prst="rect">
+            <a:avLst/>
+          </a:prstGeom>
+          <a:solidFill>
+            <a:srgbClr val="C0392B"/>
+          </a:solidFill>
+          <a:ln>
+            <a:noFill/>
+          </a:ln>
+          <a:effectLst/>
+        </p:spPr>
+        <p:style>
+          <a:lnRef idx="1">
+            <a:schemeClr val="accent1"/>
+          </a:lnRef>
+          <a:fillRef idx="3">
+            <a:schemeClr val="accent1"/>
+          </a:fillRef>
+          <a:effectRef idx="2">
+            <a:schemeClr val="accent1"/>
+          </a:effectRef>
+          <a:fontRef idx="minor">
+            <a:schemeClr val="lt1"/>
+          </a:fontRef>
+        </p:style>
+        <p:txBody>
+          <a:bodyPr rtlCol="0" anchor="t" wrap="square" lIns="73152" rIns="73152" tIns="27432" bIns="27432"/>
+          <a:lstStyle/>
+          <a:p>
+            <a:pPr algn="ctr"/>
+          </a:p>
+        </p:txBody>
+      </p:sp>
+      <p:sp>
+        <p:nvSpPr>
+          <p:cNvPr id="25" name="Rectangle 24"/>
+          <p:cNvSpPr/>
+          <p:nvPr/>
+        </p:nvSpPr>
+        <p:spPr>
+          <a:xfrm>
+            <a:off x="5440680" y="3611880"/>
+            <a:ext cx="1828800" cy="237744"/>
+          </a:xfrm>
+          <a:prstGeom prst="rect">
+            <a:avLst/>
+          </a:prstGeom>
+          <a:noFill/>
+          <a:ln>
+            <a:noFill/>
+          </a:ln>
+          <a:effectLst/>
+        </p:spPr>
+        <p:style>
+          <a:lnRef idx="1">
+            <a:schemeClr val="accent1"/>
+          </a:lnRef>
+          <a:fillRef idx="3">
+            <a:schemeClr val="accent1"/>
+          </a:fillRef>
+          <a:effectRef idx="2">
+            <a:schemeClr val="accent1"/>
+          </a:effectRef>
+          <a:fontRef idx="minor">
+            <a:schemeClr val="lt1"/>
+          </a:fontRef>
+        </p:style>
+        <p:txBody>
+          <a:bodyPr rtlCol="0" anchor="t" wrap="square" lIns="73152" rIns="73152" tIns="27432" bIns="27432"/>
+          <a:lstStyle/>
+          <a:p>
+            <a:pPr algn="ctr">
+              <a:spcBef>
+                <a:spcPts val="0"/>
+              </a:spcBef>
+              <a:spcAft>
+                <a:spcPts val="200"/>
+              </a:spcAft>
+            </a:pPr>
+            <a:r>
+              <a:rPr sz="900" b="1">
+                <a:solidFill>
+                  <a:srgbClr val="C0392B"/>
+                </a:solidFill>
+                <a:latin typeface="Meiryo"/>
+              </a:rPr>
+              <a:t>到着ピーク 08:30・同時11便</a:t>
+            </a:r>
+          </a:p>
+        </p:txBody>
+      </p:sp>
+      <p:sp>
+        <p:nvSpPr>
+          <p:cNvPr id="26" name="Rectangle 25"/>
+          <p:cNvSpPr/>
+          <p:nvPr/>
+        </p:nvSpPr>
+        <p:spPr>
+          <a:xfrm>
+            <a:off x="10371124" y="3611880"/>
+            <a:ext cx="14630" cy="1737360"/>
+          </a:xfrm>
+          <a:prstGeom prst="rect">
+            <a:avLst/>
+          </a:prstGeom>
+          <a:solidFill>
+            <a:srgbClr val="9AA6B8"/>
+          </a:solidFill>
+          <a:ln>
+            <a:noFill/>
+          </a:ln>
+          <a:effectLst/>
+        </p:spPr>
+        <p:style>
+          <a:lnRef idx="1">
+            <a:schemeClr val="accent1"/>
+          </a:lnRef>
+          <a:fillRef idx="3">
+            <a:schemeClr val="accent1"/>
+          </a:fillRef>
+          <a:effectRef idx="2">
+            <a:schemeClr val="accent1"/>
+          </a:effectRef>
+          <a:fontRef idx="minor">
+            <a:schemeClr val="lt1"/>
+          </a:fontRef>
+        </p:style>
+        <p:txBody>
+          <a:bodyPr rtlCol="0" anchor="t" wrap="square" lIns="73152" rIns="73152" tIns="27432" bIns="27432"/>
+          <a:lstStyle/>
+          <a:p>
+            <a:pPr algn="ctr"/>
+          </a:p>
+        </p:txBody>
+      </p:sp>
+      <p:sp>
+        <p:nvSpPr>
+          <p:cNvPr id="27" name="Rectangle 26"/>
+          <p:cNvSpPr/>
+          <p:nvPr/>
+        </p:nvSpPr>
+        <p:spPr>
+          <a:xfrm>
+            <a:off x="9464040" y="3611880"/>
+            <a:ext cx="1828800" cy="237744"/>
+          </a:xfrm>
+          <a:prstGeom prst="rect">
+            <a:avLst/>
+          </a:prstGeom>
+          <a:noFill/>
+          <a:ln>
+            <a:noFill/>
+          </a:ln>
+          <a:effectLst/>
+        </p:spPr>
+        <p:style>
+          <a:lnRef idx="1">
+            <a:schemeClr val="accent1"/>
+          </a:lnRef>
+          <a:fillRef idx="3">
+            <a:schemeClr val="accent1"/>
+          </a:fillRef>
+          <a:effectRef idx="2">
+            <a:schemeClr val="accent1"/>
+          </a:effectRef>
+          <a:fontRef idx="minor">
+            <a:schemeClr val="lt1"/>
+          </a:fontRef>
+        </p:style>
+        <p:txBody>
+          <a:bodyPr rtlCol="0" anchor="t" wrap="square" lIns="73152" rIns="73152" tIns="27432" bIns="27432"/>
+          <a:lstStyle/>
+          <a:p>
+            <a:pPr algn="ctr">
+              <a:spcBef>
+                <a:spcPts val="0"/>
+              </a:spcBef>
+              <a:spcAft>
+                <a:spcPts val="200"/>
+              </a:spcAft>
+            </a:pPr>
+            <a:r>
+              <a:rPr sz="900" b="1">
+                <a:solidFill>
+                  <a:srgbClr val="9AA6B8"/>
+                </a:solidFill>
+                <a:latin typeface="Meiryo"/>
+              </a:rPr>
+              <a:t>後半出発 〜11:15</a:t>
+            </a:r>
+          </a:p>
+        </p:txBody>
+      </p:sp>
+      <p:sp>
+        <p:nvSpPr>
+          <p:cNvPr id="28" name="Rounded Rectangle 27"/>
+          <p:cNvSpPr/>
+          <p:nvPr/>
+        </p:nvSpPr>
+        <p:spPr>
+          <a:xfrm>
+            <a:off x="2331720" y="3977639"/>
+            <a:ext cx="6583680" cy="502920"/>
+          </a:xfrm>
+          <a:prstGeom prst="roundRect">
+            <a:avLst/>
+          </a:prstGeom>
+          <a:solidFill>
+            <a:srgbClr val="2E5AAC"/>
+          </a:solidFill>
+          <a:ln>
+            <a:noFill/>
+          </a:ln>
+          <a:effectLst/>
+        </p:spPr>
+        <p:style>
+          <a:lnRef idx="1">
+            <a:schemeClr val="accent1"/>
+          </a:lnRef>
+          <a:fillRef idx="3">
+            <a:schemeClr val="accent1"/>
+          </a:fillRef>
+          <a:effectRef idx="2">
+            <a:schemeClr val="accent1"/>
+          </a:effectRef>
+          <a:fontRef idx="minor">
+            <a:schemeClr val="lt1"/>
+          </a:fontRef>
+        </p:style>
+        <p:txBody>
+          <a:bodyPr rtlCol="0" anchor="ctr" wrap="square" lIns="73152" rIns="73152" tIns="27432" bIns="27432"/>
+          <a:lstStyle/>
+          <a:p>
+            <a:pPr algn="ctr">
+              <a:spcBef>
+                <a:spcPts val="0"/>
+              </a:spcBef>
+              <a:spcAft>
+                <a:spcPts val="200"/>
+              </a:spcAft>
+            </a:pPr>
+            <a:r>
+              <a:rPr sz="1200" b="1">
+                <a:solidFill>
+                  <a:srgbClr val="FFFFFF"/>
+                </a:solidFill>
+                <a:latin typeface="Meiryo"/>
+              </a:rPr>
+              <a:t>早番A</a:t>
+            </a:r>
+          </a:p>
+        </p:txBody>
+      </p:sp>
+      <p:sp>
+        <p:nvSpPr>
+          <p:cNvPr id="29" name="Rounded Rectangle 28"/>
+          <p:cNvSpPr/>
+          <p:nvPr/>
+        </p:nvSpPr>
+        <p:spPr>
+          <a:xfrm>
+            <a:off x="4892040" y="4617720"/>
+            <a:ext cx="6583679" cy="502920"/>
+          </a:xfrm>
+          <a:prstGeom prst="roundRect">
+            <a:avLst/>
+          </a:prstGeom>
+          <a:solidFill>
+            <a:srgbClr val="2C6E49"/>
+          </a:solidFill>
+          <a:ln>
+            <a:noFill/>
+          </a:ln>
+          <a:effectLst/>
+        </p:spPr>
+        <p:style>
+          <a:lnRef idx="1">
+            <a:schemeClr val="accent1"/>
+          </a:lnRef>
+          <a:fillRef idx="3">
+            <a:schemeClr val="accent1"/>
+          </a:fillRef>
+          <a:effectRef idx="2">
+            <a:schemeClr val="accent1"/>
+          </a:effectRef>
+          <a:fontRef idx="minor">
+            <a:schemeClr val="lt1"/>
+          </a:fontRef>
+        </p:style>
+        <p:txBody>
+          <a:bodyPr rtlCol="0" anchor="ctr" wrap="square" lIns="73152" rIns="73152" tIns="27432" bIns="27432"/>
+          <a:lstStyle/>
+          <a:p>
+            <a:pPr algn="ctr">
+              <a:spcBef>
+                <a:spcPts val="0"/>
+              </a:spcBef>
+              <a:spcAft>
+                <a:spcPts val="200"/>
+              </a:spcAft>
+            </a:pPr>
+            <a:r>
+              <a:rPr sz="1200" b="1">
+                <a:solidFill>
+                  <a:srgbClr val="FFFFFF"/>
+                </a:solidFill>
+                <a:latin typeface="Meiryo"/>
+              </a:rPr>
+              <a:t>中番B</a:t>
+            </a:r>
+          </a:p>
+        </p:txBody>
+      </p:sp>
+      <p:sp>
+        <p:nvSpPr>
+          <p:cNvPr id="30" name="Rectangle 29"/>
+          <p:cNvSpPr/>
+          <p:nvPr/>
+        </p:nvSpPr>
+        <p:spPr>
+          <a:xfrm>
+            <a:off x="548640" y="5669280"/>
+            <a:ext cx="11064240" cy="502920"/>
+          </a:xfrm>
+          <a:prstGeom prst="rect">
+            <a:avLst/>
+          </a:prstGeom>
+          <a:solidFill>
+            <a:srgbClr val="E5ECF7"/>
+          </a:solidFill>
+          <a:ln w="12700">
+            <a:solidFill>
+              <a:srgbClr val="D9DFEA"/>
+            </a:solidFill>
+          </a:ln>
+          <a:effectLst/>
+        </p:spPr>
+        <p:style>
+          <a:lnRef idx="1">
+            <a:schemeClr val="accent1"/>
+          </a:lnRef>
+          <a:fillRef idx="3">
+            <a:schemeClr val="accent1"/>
+          </a:fillRef>
+          <a:effectRef idx="2">
+            <a:schemeClr val="accent1"/>
+          </a:effectRef>
+          <a:fontRef idx="minor">
+            <a:schemeClr val="lt1"/>
+          </a:fontRef>
+        </p:style>
+        <p:txBody>
+          <a:bodyPr rtlCol="0" anchor="ctr" wrap="square" lIns="73152" rIns="73152" tIns="27432" bIns="27432"/>
+          <a:lstStyle/>
+          <a:p>
+            <a:pPr algn="ctr">
+              <a:spcBef>
+                <a:spcPts val="0"/>
+              </a:spcBef>
+              <a:spcAft>
+                <a:spcPts val="200"/>
+              </a:spcAft>
+            </a:pPr>
+            <a:r>
+              <a:rPr sz="1500" b="1">
+                <a:solidFill>
+                  <a:srgbClr val="1B2A4A"/>
+                </a:solidFill>
+                <a:latin typeface="Meiryo"/>
+              </a:rPr>
+              <a:t>重なる 07:30–10:15 が一番人手が要る時間。早番と中番の二枚重ねで厚くする。</a:t>
+            </a:r>
+          </a:p>
+        </p:txBody>
+      </p:sp>
+      <p:sp>
+        <p:nvSpPr>
+          <p:cNvPr id="31" name="Rectangle 30"/>
+          <p:cNvSpPr/>
+          <p:nvPr/>
+        </p:nvSpPr>
+        <p:spPr>
+          <a:xfrm>
+            <a:off x="548640" y="6217920"/>
+            <a:ext cx="11064240" cy="201168"/>
+          </a:xfrm>
+          <a:prstGeom prst="rect">
+            <a:avLst/>
+          </a:prstGeom>
+          <a:noFill/>
+          <a:ln>
+            <a:noFill/>
+          </a:ln>
+          <a:effectLst/>
+        </p:spPr>
+        <p:style>
+          <a:lnRef idx="1">
+            <a:schemeClr val="accent1"/>
+          </a:lnRef>
+          <a:fillRef idx="3">
+            <a:schemeClr val="accent1"/>
+          </a:fillRef>
+          <a:effectRef idx="2">
+            <a:schemeClr val="accent1"/>
+          </a:effectRef>
+          <a:fontRef idx="minor">
+            <a:schemeClr val="lt1"/>
+          </a:fontRef>
+        </p:style>
+        <p:txBody>
+          <a:bodyPr rtlCol="0" anchor="t" wrap="square" lIns="73152" rIns="73152" tIns="27432" bIns="27432"/>
+          <a:lstStyle/>
+          <a:p>
+            <a:pPr algn="l">
+              <a:spcBef>
+                <a:spcPts val="0"/>
+              </a:spcBef>
+              <a:spcAft>
+                <a:spcPts val="200"/>
+              </a:spcAft>
+            </a:pPr>
+            <a:r>
+              <a:rPr sz="900" b="0">
+                <a:solidFill>
+                  <a:srgbClr val="9AA6B8"/>
+                </a:solidFill>
+                <a:latin typeface="Meiryo"/>
+              </a:rPr>
+              <a:t>※ シフト時刻は提案値（実線表の2波に合わせて設定）。各シフトの必要人数は支店が線表×SLAで確定。</a:t>
+            </a:r>
+          </a:p>
+        </p:txBody>
+      </p:sp>
+      <p:sp>
+        <p:nvSpPr>
+          <p:cNvPr id="32" name="Rectangle 31"/>
+          <p:cNvSpPr/>
+          <p:nvPr/>
+        </p:nvSpPr>
+        <p:spPr>
+          <a:xfrm>
+            <a:off x="457200" y="6419088"/>
+            <a:ext cx="5486400" cy="274320"/>
+          </a:xfrm>
+          <a:prstGeom prst="rect">
+            <a:avLst/>
+          </a:prstGeom>
+          <a:noFill/>
+          <a:ln>
+            <a:noFill/>
+          </a:ln>
+          <a:effectLst/>
+        </p:spPr>
+        <p:style>
+          <a:lnRef idx="1">
+            <a:schemeClr val="accent1"/>
+          </a:lnRef>
+          <a:fillRef idx="3">
+            <a:schemeClr val="accent1"/>
+          </a:fillRef>
+          <a:effectRef idx="2">
+            <a:schemeClr val="accent1"/>
+          </a:effectRef>
+          <a:fontRef idx="minor">
+            <a:schemeClr val="lt1"/>
+          </a:fontRef>
+        </p:style>
+        <p:txBody>
+          <a:bodyPr rtlCol="0" anchor="t" wrap="square" lIns="73152" rIns="73152" tIns="27432" bIns="27432"/>
+          <a:lstStyle/>
+          <a:p>
+            <a:pPr algn="l">
+              <a:spcBef>
+                <a:spcPts val="0"/>
+              </a:spcBef>
+              <a:spcAft>
+                <a:spcPts val="200"/>
+              </a:spcAft>
+            </a:pPr>
+            <a:r>
+              <a:rPr sz="900" b="0">
+                <a:solidFill>
+                  <a:srgbClr val="6B7686"/>
+                </a:solidFill>
+                <a:latin typeface="Meiryo"/>
+              </a:rPr>
+              <a:t>短時間勤務者採用 説明会</a:t>
+            </a:r>
+          </a:p>
+        </p:txBody>
+      </p:sp>
+      <p:sp>
+        <p:nvSpPr>
+          <p:cNvPr id="33" name="Rectangle 32"/>
+          <p:cNvSpPr/>
+          <p:nvPr/>
+        </p:nvSpPr>
+        <p:spPr>
+          <a:xfrm>
+            <a:off x="11155680" y="6419088"/>
+            <a:ext cx="640080" cy="274320"/>
+          </a:xfrm>
+          <a:prstGeom prst="rect">
+            <a:avLst/>
+          </a:prstGeom>
+          <a:noFill/>
+          <a:ln>
+            <a:noFill/>
+          </a:ln>
+          <a:effectLst/>
+        </p:spPr>
+        <p:style>
+          <a:lnRef idx="1">
+            <a:schemeClr val="accent1"/>
+          </a:lnRef>
+          <a:fillRef idx="3">
+            <a:schemeClr val="accent1"/>
+          </a:fillRef>
+          <a:effectRef idx="2">
+            <a:schemeClr val="accent1"/>
+          </a:effectRef>
+          <a:fontRef idx="minor">
+            <a:schemeClr val="lt1"/>
+          </a:fontRef>
+        </p:style>
+        <p:txBody>
+          <a:bodyPr rtlCol="0" anchor="t" wrap="square" lIns="73152" rIns="73152" tIns="27432" bIns="27432"/>
+          <a:lstStyle/>
+          <a:p>
+            <a:pPr algn="r">
+              <a:spcBef>
+                <a:spcPts val="0"/>
+              </a:spcBef>
+              <a:spcAft>
+                <a:spcPts val="200"/>
+              </a:spcAft>
+            </a:pPr>
+            <a:r>
+              <a:rPr sz="900" b="0">
+                <a:solidFill>
+                  <a:srgbClr val="6B7686"/>
+                </a:solidFill>
+                <a:latin typeface="Meiryo"/>
+              </a:rPr>
+              <a:t>20</a:t>
+            </a:r>
+          </a:p>
+        </p:txBody>
+      </p:sp>
+    </p:spTree>
+  </p:cSld>
+  <p:clrMapOvr>
+    <a:masterClrMapping/>
+  </p:clrMapOvr>
+</p:sld>
+</file>
+
+<file path=ppt/slides/slide28.xml><?xml version="1.0" encoding="utf-8"?>
+<p:sld xmlns:a="http://schemas.openxmlformats.org/drawingml/2006/main" xmlns:p="http://schemas.openxmlformats.org/presentationml/2006/main" xmlns:r="http://schemas.openxmlformats.org/officeDocument/2006/relationships">
+  <p:cSld>
+    <p:spTree>
+      <p:nvGrpSpPr>
+        <p:cNvPr id="1" name=""/>
+        <p:cNvGrpSpPr/>
+        <p:nvPr/>
+      </p:nvGrpSpPr>
+      <p:grpSpPr/>
+      <p:sp>
+        <p:nvSpPr>
+          <p:cNvPr id="2" name="Rectangle 1"/>
+          <p:cNvSpPr/>
+          <p:nvPr/>
+        </p:nvSpPr>
+        <p:spPr>
+          <a:xfrm>
+            <a:off x="548640" y="502920"/>
+            <a:ext cx="10789920" cy="320040"/>
+          </a:xfrm>
+          <a:prstGeom prst="rect">
+            <a:avLst/>
+          </a:prstGeom>
+          <a:noFill/>
+          <a:ln>
+            <a:noFill/>
+          </a:ln>
+          <a:effectLst/>
+        </p:spPr>
+        <p:style>
+          <a:lnRef idx="1">
+            <a:schemeClr val="accent1"/>
+          </a:lnRef>
+          <a:fillRef idx="3">
+            <a:schemeClr val="accent1"/>
+          </a:fillRef>
+          <a:effectRef idx="2">
+            <a:schemeClr val="accent1"/>
+          </a:effectRef>
+          <a:fontRef idx="minor">
+            <a:schemeClr val="lt1"/>
+          </a:fontRef>
+        </p:style>
+        <p:txBody>
+          <a:bodyPr rtlCol="0" anchor="t" wrap="square" lIns="73152" rIns="73152" tIns="27432" bIns="27432"/>
+          <a:lstStyle/>
+          <a:p>
+            <a:pPr algn="l">
+              <a:spcBef>
+                <a:spcPts val="0"/>
+              </a:spcBef>
+              <a:spcAft>
+                <a:spcPts val="200"/>
+              </a:spcAft>
+            </a:pPr>
+            <a:r>
+              <a:rPr sz="1300" b="1">
+                <a:solidFill>
+                  <a:srgbClr val="2E5AAC"/>
+                </a:solidFill>
+                <a:latin typeface="Meiryo"/>
+              </a:rPr>
+              <a:t>現場での活用｜配置の割付（人事部案）</a:t>
+            </a:r>
+          </a:p>
+        </p:txBody>
+      </p:sp>
+      <p:sp>
+        <p:nvSpPr>
+          <p:cNvPr id="3" name="Rectangle 2"/>
+          <p:cNvSpPr/>
+          <p:nvPr/>
+        </p:nvSpPr>
+        <p:spPr>
+          <a:xfrm>
+            <a:off x="548640" y="841248"/>
+            <a:ext cx="11064240" cy="914400"/>
+          </a:xfrm>
+          <a:prstGeom prst="rect">
+            <a:avLst/>
+          </a:prstGeom>
+          <a:noFill/>
+          <a:ln>
+            <a:noFill/>
+          </a:ln>
+          <a:effectLst/>
+        </p:spPr>
+        <p:style>
+          <a:lnRef idx="1">
+            <a:schemeClr val="accent1"/>
+          </a:lnRef>
+          <a:fillRef idx="3">
+            <a:schemeClr val="accent1"/>
+          </a:fillRef>
+          <a:effectRef idx="2">
+            <a:schemeClr val="accent1"/>
+          </a:effectRef>
+          <a:fontRef idx="minor">
+            <a:schemeClr val="lt1"/>
+          </a:fontRef>
+        </p:style>
+        <p:txBody>
+          <a:bodyPr rtlCol="0" anchor="t" wrap="square" lIns="73152" rIns="73152" tIns="27432" bIns="27432"/>
+          <a:lstStyle/>
+          <a:p>
+            <a:pPr algn="l">
+              <a:spcBef>
+                <a:spcPts val="0"/>
+              </a:spcBef>
+              <a:spcAft>
+                <a:spcPts val="200"/>
+              </a:spcAft>
+            </a:pPr>
+            <a:r>
+              <a:rPr sz="3000" b="1">
+                <a:solidFill>
+                  <a:srgbClr val="1B2A4A"/>
+                </a:solidFill>
+                <a:latin typeface="Meiryo"/>
+              </a:rPr>
+              <a:t>どのキャリアを、どの時間帯に</a:t>
+            </a:r>
+          </a:p>
+        </p:txBody>
+      </p:sp>
+      <p:graphicFrame>
+        <p:nvGraphicFramePr>
+          <p:cNvPr id="4" name="Table 3"/>
+          <p:cNvGraphicFramePr>
+            <a:graphicFrameLocks noGrp="1"/>
+          </p:cNvGraphicFramePr>
+          <p:nvPr/>
+        </p:nvGraphicFramePr>
+        <p:xfrm>
+          <a:off x="548640" y="2057400"/>
+          <a:ext cx="11155680" cy="3566160"/>
+        </p:xfrm>
+        <a:graphic>
+          <a:graphicData uri="http://schemas.openxmlformats.org/drawingml/2006/table">
+            <a:tbl>
+              <a:tblPr>
+                <a:tableStyleId>{5C22544A-7EE6-4342-B048-85BDC9FD1C3A}</a:tableStyleId>
+              </a:tblPr>
+              <a:tblGrid>
+                <a:gridCol w="1828800"/>
+                <a:gridCol w="2926080"/>
+                <a:gridCol w="2926080"/>
+                <a:gridCol w="3474720"/>
+              </a:tblGrid>
+              <a:tr h="509451">
+                <a:tc>
+                  <a:txBody>
+                    <a:bodyPr/>
+                    <a:lstStyle/>
+                    <a:p>
+                      <a:pPr algn="ctr"/>
+                      <a:r>
+                        <a:rPr sz="1200" b="1">
+                          <a:solidFill>
+                            <a:srgbClr val="FFFFFF"/>
+                          </a:solidFill>
+                          <a:latin typeface="Meiryo"/>
+                        </a:rPr>
+                        <a:t>キャリア</a:t>
+                      </a:r>
+                    </a:p>
+                  </a:txBody>
+                  <a:tcPr marL="54864" marR="54864" marT="27432" marB="27432" anchor="ctr">
+                    <a:solidFill>
+                      <a:srgbClr val="1B2A4A"/>
+                    </a:solidFill>
+                  </a:tcPr>
+                </a:tc>
+                <a:tc>
+                  <a:txBody>
+                    <a:bodyPr/>
+                    <a:lstStyle/>
+                    <a:p>
+                      <a:pPr algn="ctr"/>
+                      <a:r>
+                        <a:rPr sz="1200" b="1">
+                          <a:solidFill>
+                            <a:srgbClr val="FFFFFF"/>
+                          </a:solidFill>
+                          <a:latin typeface="Meiryo"/>
+                        </a:rPr>
+                        <a:t>早番A (05:45–10:15)</a:t>
+                      </a:r>
+                    </a:p>
+                  </a:txBody>
+                  <a:tcPr marL="54864" marR="54864" marT="27432" marB="27432" anchor="ctr">
+                    <a:solidFill>
+                      <a:srgbClr val="1B2A4A"/>
+                    </a:solidFill>
+                  </a:tcPr>
+                </a:tc>
+                <a:tc>
+                  <a:txBody>
+                    <a:bodyPr/>
+                    <a:lstStyle/>
+                    <a:p>
+                      <a:pPr algn="ctr"/>
+                      <a:r>
+                        <a:rPr sz="1200" b="1">
+                          <a:solidFill>
+                            <a:srgbClr val="FFFFFF"/>
+                          </a:solidFill>
+                          <a:latin typeface="Meiryo"/>
+                        </a:rPr>
+                        <a:t>中番B (07:30–12:00)</a:t>
+                      </a:r>
+                    </a:p>
+                  </a:txBody>
+                  <a:tcPr marL="54864" marR="54864" marT="27432" marB="27432" anchor="ctr">
+                    <a:solidFill>
+                      <a:srgbClr val="1B2A4A"/>
+                    </a:solidFill>
+                  </a:tcPr>
+                </a:tc>
+                <a:tc>
+                  <a:txBody>
+                    <a:bodyPr/>
+                    <a:lstStyle/>
+                    <a:p>
+                      <a:pPr algn="ctr"/>
+                      <a:r>
+                        <a:rPr sz="1200" b="1">
+                          <a:solidFill>
+                            <a:srgbClr val="FFFFFF"/>
+                          </a:solidFill>
+                          <a:latin typeface="Meiryo"/>
+                        </a:rPr>
+                        <a:t>主な便・備考</a:t>
+                      </a:r>
+                    </a:p>
+                  </a:txBody>
+                  <a:tcPr marL="54864" marR="54864" marT="27432" marB="27432" anchor="ctr">
+                    <a:solidFill>
+                      <a:srgbClr val="1B2A4A"/>
+                    </a:solidFill>
+                  </a:tcPr>
+                </a:tc>
+              </a:tr>
+              <a:tr h="509451">
+                <a:tc>
+                  <a:txBody>
+                    <a:bodyPr/>
+                    <a:lstStyle/>
+                    <a:p>
+                      <a:pPr algn="ctr"/>
+                      <a:r>
+                        <a:rPr sz="1300" b="1">
+                          <a:solidFill>
+                            <a:srgbClr val="1B2A4A"/>
+                          </a:solidFill>
+                          <a:latin typeface="Meiryo"/>
+                        </a:rPr>
+                        <a:t>AM</a:t>
+                      </a:r>
+                    </a:p>
+                  </a:txBody>
+                  <a:tcPr marL="54864" marR="54864" marT="27432" marB="27432" anchor="ctr">
+                    <a:solidFill>
+                      <a:srgbClr val="F3F4F7"/>
+                    </a:solidFill>
+                  </a:tcPr>
+                </a:tc>
+                <a:tc>
+                  <a:txBody>
+                    <a:bodyPr/>
+                    <a:lstStyle/>
+                    <a:p>
+                      <a:pPr algn="ctr"/>
+                      <a:r>
+                        <a:rPr sz="1500" b="1">
+                          <a:solidFill>
+                            <a:srgbClr val="2E5AAC"/>
+                          </a:solidFill>
+                          <a:latin typeface="Meiryo"/>
+                        </a:rPr>
+                        <a:t>◯</a:t>
+                      </a:r>
+                    </a:p>
+                  </a:txBody>
+                  <a:tcPr marL="54864" marR="54864" marT="27432" marB="27432" anchor="ctr">
+                    <a:solidFill>
+                      <a:srgbClr val="E5ECF7"/>
+                    </a:solidFill>
+                  </a:tcPr>
+                </a:tc>
+                <a:tc>
+                  <a:txBody>
+                    <a:bodyPr/>
+                    <a:lstStyle/>
+                    <a:p>
+                      <a:pPr algn="ctr"/>
+                      <a:r>
+                        <a:rPr sz="1500" b="1">
+                          <a:solidFill>
+                            <a:srgbClr val="2C6E49"/>
+                          </a:solidFill>
+                          <a:latin typeface="Meiryo"/>
+                        </a:rPr>
+                        <a:t/>
+                      </a:r>
+                    </a:p>
+                  </a:txBody>
+                  <a:tcPr marL="54864" marR="54864" marT="27432" marB="27432" anchor="ctr">
+                    <a:solidFill>
+                      <a:srgbClr val="FFFFFF"/>
+                    </a:solidFill>
+                  </a:tcPr>
+                </a:tc>
+                <a:tc>
+                  <a:txBody>
+                    <a:bodyPr/>
+                    <a:lstStyle/>
+                    <a:p>
+                      <a:pPr algn="l"/>
+                      <a:r>
+                        <a:rPr sz="1100" b="0">
+                          <a:solidFill>
+                            <a:srgbClr val="1F2733"/>
+                          </a:solidFill>
+                          <a:latin typeface="Meiryo"/>
+                        </a:rPr>
+                        <a:t>AM058/057（着06:30・発09:35）ワイド</a:t>
+                      </a:r>
+                    </a:p>
+                  </a:txBody>
+                  <a:tcPr marL="54864" marR="54864" marT="27432" marB="27432" anchor="ctr">
+                    <a:solidFill>
+                      <a:srgbClr val="FFFFFF"/>
+                    </a:solidFill>
+                  </a:tcPr>
+                </a:tc>
+              </a:tr>
+              <a:tr h="509451">
+                <a:tc>
+                  <a:txBody>
+                    <a:bodyPr/>
+                    <a:lstStyle/>
+                    <a:p>
+                      <a:pPr algn="ctr"/>
+                      <a:r>
+                        <a:rPr sz="1300" b="1">
+                          <a:solidFill>
+                            <a:srgbClr val="1B2A4A"/>
+                          </a:solidFill>
+                          <a:latin typeface="Meiryo"/>
+                        </a:rPr>
+                        <a:t>VN</a:t>
+                      </a:r>
+                    </a:p>
+                  </a:txBody>
+                  <a:tcPr marL="54864" marR="54864" marT="27432" marB="27432" anchor="ctr">
+                    <a:solidFill>
+                      <a:srgbClr val="F3F4F7"/>
+                    </a:solidFill>
+                  </a:tcPr>
+                </a:tc>
+                <a:tc>
+                  <a:txBody>
+                    <a:bodyPr/>
+                    <a:lstStyle/>
+                    <a:p>
+                      <a:pPr algn="ctr"/>
+                      <a:r>
+                        <a:rPr sz="1500" b="1">
+                          <a:solidFill>
+                            <a:srgbClr val="2E5AAC"/>
+                          </a:solidFill>
+                          <a:latin typeface="Meiryo"/>
+                        </a:rPr>
+                        <a:t>◯</a:t>
+                      </a:r>
+                    </a:p>
+                  </a:txBody>
+                  <a:tcPr marL="54864" marR="54864" marT="27432" marB="27432" anchor="ctr">
+                    <a:solidFill>
+                      <a:srgbClr val="E5ECF7"/>
+                    </a:solidFill>
+                  </a:tcPr>
+                </a:tc>
+                <a:tc>
+                  <a:txBody>
+                    <a:bodyPr/>
+                    <a:lstStyle/>
+                    <a:p>
+                      <a:pPr algn="ctr"/>
+                      <a:r>
+                        <a:rPr sz="1500" b="1">
+                          <a:solidFill>
+                            <a:srgbClr val="2C6E49"/>
+                          </a:solidFill>
+                          <a:latin typeface="Meiryo"/>
+                        </a:rPr>
+                        <a:t>◯</a:t>
+                      </a:r>
+                    </a:p>
+                  </a:txBody>
+                  <a:tcPr marL="54864" marR="54864" marT="27432" marB="27432" anchor="ctr">
+                    <a:solidFill>
+                      <a:srgbClr val="E3F0EA"/>
+                    </a:solidFill>
+                  </a:tcPr>
+                </a:tc>
+                <a:tc>
+                  <a:txBody>
+                    <a:bodyPr/>
+                    <a:lstStyle/>
+                    <a:p>
+                      <a:pPr algn="l"/>
+                      <a:r>
+                        <a:rPr sz="1100" b="0">
+                          <a:solidFill>
+                            <a:srgbClr val="1F2733"/>
+                          </a:solidFill>
+                          <a:latin typeface="Meiryo"/>
+                        </a:rPr>
+                        <a:t>早番：VN318/310/306　中番：VN316/317</a:t>
+                      </a:r>
+                    </a:p>
+                  </a:txBody>
+                  <a:tcPr marL="54864" marR="54864" marT="27432" marB="27432" anchor="ctr">
+                    <a:solidFill>
+                      <a:srgbClr val="FFFFFF"/>
+                    </a:solidFill>
+                  </a:tcPr>
+                </a:tc>
+              </a:tr>
+              <a:tr h="509451">
+                <a:tc>
+                  <a:txBody>
+                    <a:bodyPr/>
+                    <a:lstStyle/>
+                    <a:p>
+                      <a:pPr algn="ctr"/>
+                      <a:r>
+                        <a:rPr sz="1300" b="1">
+                          <a:solidFill>
+                            <a:srgbClr val="1B2A4A"/>
+                          </a:solidFill>
+                          <a:latin typeface="Meiryo"/>
+                        </a:rPr>
+                        <a:t>VJ</a:t>
+                      </a:r>
+                    </a:p>
+                  </a:txBody>
+                  <a:tcPr marL="54864" marR="54864" marT="27432" marB="27432" anchor="ctr">
+                    <a:solidFill>
+                      <a:srgbClr val="F3F4F7"/>
+                    </a:solidFill>
+                  </a:tcPr>
+                </a:tc>
+                <a:tc>
+                  <a:txBody>
+                    <a:bodyPr/>
+                    <a:lstStyle/>
+                    <a:p>
+                      <a:pPr algn="ctr"/>
+                      <a:r>
+                        <a:rPr sz="1500" b="1">
+                          <a:solidFill>
+                            <a:srgbClr val="2E5AAC"/>
+                          </a:solidFill>
+                          <a:latin typeface="Meiryo"/>
+                        </a:rPr>
+                        <a:t>◯</a:t>
+                      </a:r>
+                    </a:p>
+                  </a:txBody>
+                  <a:tcPr marL="54864" marR="54864" marT="27432" marB="27432" anchor="ctr">
+                    <a:solidFill>
+                      <a:srgbClr val="E5ECF7"/>
+                    </a:solidFill>
+                  </a:tcPr>
+                </a:tc>
+                <a:tc>
+                  <a:txBody>
+                    <a:bodyPr/>
+                    <a:lstStyle/>
+                    <a:p>
+                      <a:pPr algn="ctr"/>
+                      <a:r>
+                        <a:rPr sz="1500" b="1">
+                          <a:solidFill>
+                            <a:srgbClr val="2C6E49"/>
+                          </a:solidFill>
+                          <a:latin typeface="Meiryo"/>
+                        </a:rPr>
+                        <a:t/>
+                      </a:r>
+                    </a:p>
+                  </a:txBody>
+                  <a:tcPr marL="54864" marR="54864" marT="27432" marB="27432" anchor="ctr">
+                    <a:solidFill>
+                      <a:srgbClr val="FFFFFF"/>
+                    </a:solidFill>
+                  </a:tcPr>
+                </a:tc>
+                <a:tc>
+                  <a:txBody>
+                    <a:bodyPr/>
+                    <a:lstStyle/>
+                    <a:p>
+                      <a:pPr algn="l"/>
+                      <a:r>
+                        <a:rPr sz="1100" b="0">
+                          <a:solidFill>
+                            <a:srgbClr val="1F2733"/>
+                          </a:solidFill>
+                          <a:latin typeface="Meiryo"/>
+                        </a:rPr>
+                        <a:t>VJ822・VJ932（夕方便はWinter条件付）</a:t>
+                      </a:r>
+                    </a:p>
+                  </a:txBody>
+                  <a:tcPr marL="54864" marR="54864" marT="27432" marB="27432" anchor="ctr">
+                    <a:solidFill>
+                      <a:srgbClr val="FFFFFF"/>
+                    </a:solidFill>
+                  </a:tcPr>
+                </a:tc>
+              </a:tr>
+              <a:tr h="509451">
+                <a:tc>
+                  <a:txBody>
+                    <a:bodyPr/>
+                    <a:lstStyle/>
+                    <a:p>
+                      <a:pPr algn="ctr"/>
+                      <a:r>
+                        <a:rPr sz="1300" b="1">
+                          <a:solidFill>
+                            <a:srgbClr val="1B2A4A"/>
+                          </a:solidFill>
+                          <a:latin typeface="Meiryo"/>
+                        </a:rPr>
+                        <a:t>5J</a:t>
+                      </a:r>
+                    </a:p>
+                  </a:txBody>
+                  <a:tcPr marL="54864" marR="54864" marT="27432" marB="27432" anchor="ctr">
+                    <a:solidFill>
+                      <a:srgbClr val="F3F4F7"/>
+                    </a:solidFill>
+                  </a:tcPr>
+                </a:tc>
+                <a:tc>
+                  <a:txBody>
+                    <a:bodyPr/>
+                    <a:lstStyle/>
+                    <a:p>
+                      <a:pPr algn="ctr"/>
+                      <a:r>
+                        <a:rPr sz="1500" b="1">
+                          <a:solidFill>
+                            <a:srgbClr val="2E5AAC"/>
+                          </a:solidFill>
+                          <a:latin typeface="Meiryo"/>
+                        </a:rPr>
+                        <a:t>◯</a:t>
+                      </a:r>
+                    </a:p>
+                  </a:txBody>
+                  <a:tcPr marL="54864" marR="54864" marT="27432" marB="27432" anchor="ctr">
+                    <a:solidFill>
+                      <a:srgbClr val="E5ECF7"/>
+                    </a:solidFill>
+                  </a:tcPr>
+                </a:tc>
+                <a:tc>
+                  <a:txBody>
+                    <a:bodyPr/>
+                    <a:lstStyle/>
+                    <a:p>
+                      <a:pPr algn="ctr"/>
+                      <a:r>
+                        <a:rPr sz="1500" b="1">
+                          <a:solidFill>
+                            <a:srgbClr val="2C6E49"/>
+                          </a:solidFill>
+                          <a:latin typeface="Meiryo"/>
+                        </a:rPr>
+                        <a:t>◯</a:t>
+                      </a:r>
+                    </a:p>
+                  </a:txBody>
+                  <a:tcPr marL="54864" marR="54864" marT="27432" marB="27432" anchor="ctr">
+                    <a:solidFill>
+                      <a:srgbClr val="E3F0EA"/>
+                    </a:solidFill>
+                  </a:tcPr>
+                </a:tc>
+                <a:tc>
+                  <a:txBody>
+                    <a:bodyPr/>
+                    <a:lstStyle/>
+                    <a:p>
+                      <a:pPr algn="l"/>
+                      <a:r>
+                        <a:rPr sz="1100" b="0">
+                          <a:solidFill>
+                            <a:srgbClr val="1F2733"/>
+                          </a:solidFill>
+                          <a:latin typeface="Meiryo"/>
+                        </a:rPr>
+                        <a:t>早番：5J5062　中番：5J5068（昼・夕は別枠）</a:t>
+                      </a:r>
+                    </a:p>
+                  </a:txBody>
+                  <a:tcPr marL="54864" marR="54864" marT="27432" marB="27432" anchor="ctr">
+                    <a:solidFill>
+                      <a:srgbClr val="FFFFFF"/>
+                    </a:solidFill>
+                  </a:tcPr>
+                </a:tc>
+              </a:tr>
+              <a:tr h="509451">
+                <a:tc>
+                  <a:txBody>
+                    <a:bodyPr/>
+                    <a:lstStyle/>
+                    <a:p>
+                      <a:pPr algn="ctr"/>
+                      <a:r>
+                        <a:rPr sz="1300" b="1">
+                          <a:solidFill>
+                            <a:srgbClr val="1B2A4A"/>
+                          </a:solidFill>
+                          <a:latin typeface="Meiryo"/>
+                        </a:rPr>
+                        <a:t>UL</a:t>
+                      </a:r>
+                    </a:p>
+                  </a:txBody>
+                  <a:tcPr marL="54864" marR="54864" marT="27432" marB="27432" anchor="ctr">
+                    <a:solidFill>
+                      <a:srgbClr val="F3F4F7"/>
+                    </a:solidFill>
+                  </a:tcPr>
+                </a:tc>
+                <a:tc>
+                  <a:txBody>
+                    <a:bodyPr/>
+                    <a:lstStyle/>
+                    <a:p>
+                      <a:pPr algn="ctr"/>
+                      <a:r>
+                        <a:rPr sz="1500" b="1">
+                          <a:solidFill>
+                            <a:srgbClr val="2E5AAC"/>
+                          </a:solidFill>
+                          <a:latin typeface="Meiryo"/>
+                        </a:rPr>
+                        <a:t/>
+                      </a:r>
+                    </a:p>
+                  </a:txBody>
+                  <a:tcPr marL="54864" marR="54864" marT="27432" marB="27432" anchor="ctr">
+                    <a:solidFill>
+                      <a:srgbClr val="FFFFFF"/>
+                    </a:solidFill>
+                  </a:tcPr>
+                </a:tc>
+                <a:tc>
+                  <a:txBody>
+                    <a:bodyPr/>
+                    <a:lstStyle/>
+                    <a:p>
+                      <a:pPr algn="ctr"/>
+                      <a:r>
+                        <a:rPr sz="1500" b="1">
+                          <a:solidFill>
+                            <a:srgbClr val="2C6E49"/>
+                          </a:solidFill>
+                          <a:latin typeface="Meiryo"/>
+                        </a:rPr>
+                        <a:t>◯</a:t>
+                      </a:r>
+                    </a:p>
+                  </a:txBody>
+                  <a:tcPr marL="54864" marR="54864" marT="27432" marB="27432" anchor="ctr">
+                    <a:solidFill>
+                      <a:srgbClr val="E3F0EA"/>
+                    </a:solidFill>
+                  </a:tcPr>
+                </a:tc>
+                <a:tc>
+                  <a:txBody>
+                    <a:bodyPr/>
+                    <a:lstStyle/>
+                    <a:p>
+                      <a:pPr algn="l"/>
+                      <a:r>
+                        <a:rPr sz="1100" b="0">
+                          <a:solidFill>
+                            <a:srgbClr val="1F2733"/>
+                          </a:solidFill>
+                          <a:latin typeface="Meiryo"/>
+                        </a:rPr>
+                        <a:t>UL454/455（08:15–11:15）※火木土・ワイド</a:t>
+                      </a:r>
+                    </a:p>
+                  </a:txBody>
+                  <a:tcPr marL="54864" marR="54864" marT="27432" marB="27432" anchor="ctr">
+                    <a:solidFill>
+                      <a:srgbClr val="FFFFFF"/>
+                    </a:solidFill>
+                  </a:tcPr>
+                </a:tc>
+              </a:tr>
+              <a:tr h="509454">
+                <a:tc>
+                  <a:txBody>
+                    <a:bodyPr/>
+                    <a:lstStyle/>
+                    <a:p>
+                      <a:pPr algn="ctr"/>
+                      <a:r>
+                        <a:rPr sz="1300" b="1">
+                          <a:solidFill>
+                            <a:srgbClr val="1B2A4A"/>
+                          </a:solidFill>
+                          <a:latin typeface="Meiryo"/>
+                        </a:rPr>
+                        <a:t>RF</a:t>
+                      </a:r>
+                    </a:p>
+                  </a:txBody>
+                  <a:tcPr marL="54864" marR="54864" marT="27432" marB="27432" anchor="ctr">
+                    <a:solidFill>
+                      <a:srgbClr val="F3F4F7"/>
+                    </a:solidFill>
+                  </a:tcPr>
+                </a:tc>
+                <a:tc>
+                  <a:txBody>
+                    <a:bodyPr/>
+                    <a:lstStyle/>
+                    <a:p>
+                      <a:pPr algn="ctr"/>
+                      <a:r>
+                        <a:rPr sz="1500" b="1">
+                          <a:solidFill>
+                            <a:srgbClr val="2E5AAC"/>
+                          </a:solidFill>
+                          <a:latin typeface="Meiryo"/>
+                        </a:rPr>
+                        <a:t/>
+                      </a:r>
+                    </a:p>
+                  </a:txBody>
+                  <a:tcPr marL="54864" marR="54864" marT="27432" marB="27432" anchor="ctr">
+                    <a:solidFill>
+                      <a:srgbClr val="FFFFFF"/>
+                    </a:solidFill>
+                  </a:tcPr>
+                </a:tc>
+                <a:tc>
+                  <a:txBody>
+                    <a:bodyPr/>
+                    <a:lstStyle/>
+                    <a:p>
+                      <a:pPr algn="ctr"/>
+                      <a:r>
+                        <a:rPr sz="1500" b="1">
+                          <a:solidFill>
+                            <a:srgbClr val="2C6E49"/>
+                          </a:solidFill>
+                          <a:latin typeface="Meiryo"/>
+                        </a:rPr>
+                        <a:t>◯</a:t>
+                      </a:r>
+                    </a:p>
+                  </a:txBody>
+                  <a:tcPr marL="54864" marR="54864" marT="27432" marB="27432" anchor="ctr">
+                    <a:solidFill>
+                      <a:srgbClr val="E3F0EA"/>
+                    </a:solidFill>
+                  </a:tcPr>
+                </a:tc>
+                <a:tc>
+                  <a:txBody>
+                    <a:bodyPr/>
+                    <a:lstStyle/>
+                    <a:p>
+                      <a:pPr algn="l"/>
+                      <a:r>
+                        <a:rPr sz="1100" b="0">
+                          <a:solidFill>
+                            <a:srgbClr val="1F2733"/>
+                          </a:solidFill>
+                          <a:latin typeface="Meiryo"/>
+                        </a:rPr>
+                        <a:t>RF392/391（08:10–10:40）</a:t>
+                      </a:r>
+                    </a:p>
+                  </a:txBody>
+                  <a:tcPr marL="54864" marR="54864" marT="27432" marB="27432" anchor="ctr">
+                    <a:solidFill>
+                      <a:srgbClr val="FFFFFF"/>
+                    </a:solidFill>
+                  </a:tcPr>
+                </a:tc>
+              </a:tr>
+            </a:tbl>
+          </a:graphicData>
+        </a:graphic>
+      </p:graphicFrame>
+      <p:sp>
+        <p:nvSpPr>
+          <p:cNvPr id="5" name="Rounded Rectangle 4"/>
+          <p:cNvSpPr/>
+          <p:nvPr/>
+        </p:nvSpPr>
+        <p:spPr>
+          <a:xfrm>
+            <a:off x="548640" y="5806440"/>
+            <a:ext cx="11064240" cy="502920"/>
+          </a:xfrm>
+          <a:prstGeom prst="roundRect">
+            <a:avLst/>
+          </a:prstGeom>
+          <a:solidFill>
+            <a:srgbClr val="1B2A4A"/>
+          </a:solidFill>
+          <a:ln>
+            <a:noFill/>
+          </a:ln>
+          <a:effectLst/>
+        </p:spPr>
+        <p:style>
+          <a:lnRef idx="1">
+            <a:schemeClr val="accent1"/>
+          </a:lnRef>
+          <a:fillRef idx="3">
+            <a:schemeClr val="accent1"/>
+          </a:fillRef>
+          <a:effectRef idx="2">
+            <a:schemeClr val="accent1"/>
+          </a:effectRef>
+          <a:fontRef idx="minor">
+            <a:schemeClr val="lt1"/>
+          </a:fontRef>
+        </p:style>
+        <p:txBody>
+          <a:bodyPr rtlCol="0" anchor="ctr" wrap="square" lIns="73152" rIns="73152" tIns="27432" bIns="27432"/>
+          <a:lstStyle/>
+          <a:p>
+            <a:pPr algn="ctr">
+              <a:spcBef>
+                <a:spcPts val="0"/>
+              </a:spcBef>
+              <a:spcAft>
+                <a:spcPts val="200"/>
+              </a:spcAft>
+            </a:pPr>
+            <a:r>
+              <a:rPr sz="1400" b="1">
+                <a:solidFill>
+                  <a:srgbClr val="FFFFFF"/>
+                </a:solidFill>
+                <a:latin typeface="Meiryo"/>
+              </a:rPr>
+              <a:t>早番A＝AM・VN・VJ・5J（前半便）／ 中番B＝UL・RF・VN(316)・5J(5068)。6社が2本のシフトに収まる。</a:t>
+            </a:r>
+          </a:p>
+        </p:txBody>
+      </p:sp>
+      <p:sp>
+        <p:nvSpPr>
+          <p:cNvPr id="6" name="Rectangle 5"/>
+          <p:cNvSpPr/>
+          <p:nvPr/>
+        </p:nvSpPr>
+        <p:spPr>
+          <a:xfrm>
+            <a:off x="548640" y="6364224"/>
+            <a:ext cx="11064240" cy="201168"/>
+          </a:xfrm>
+          <a:prstGeom prst="rect">
+            <a:avLst/>
+          </a:prstGeom>
+          <a:noFill/>
+          <a:ln>
+            <a:noFill/>
+          </a:ln>
+          <a:effectLst/>
+        </p:spPr>
+        <p:style>
+          <a:lnRef idx="1">
+            <a:schemeClr val="accent1"/>
+          </a:lnRef>
+          <a:fillRef idx="3">
+            <a:schemeClr val="accent1"/>
+          </a:fillRef>
+          <a:effectRef idx="2">
+            <a:schemeClr val="accent1"/>
+          </a:effectRef>
+          <a:fontRef idx="minor">
+            <a:schemeClr val="lt1"/>
+          </a:fontRef>
+        </p:style>
+        <p:txBody>
+          <a:bodyPr rtlCol="0" anchor="t" wrap="square" lIns="73152" rIns="73152" tIns="27432" bIns="27432"/>
+          <a:lstStyle/>
+          <a:p>
+            <a:pPr algn="l">
+              <a:spcBef>
+                <a:spcPts val="0"/>
+              </a:spcBef>
+              <a:spcAft>
+                <a:spcPts val="200"/>
+              </a:spcAft>
+            </a:pPr>
+            <a:r>
+              <a:rPr sz="900" b="0">
+                <a:solidFill>
+                  <a:srgbClr val="9AA6B8"/>
+                </a:solidFill>
+                <a:latin typeface="Meiryo"/>
+              </a:rPr>
+              <a:t>◯＝配置候補。時刻は線表の実データ。必要人数は各支店で確定。</a:t>
+            </a:r>
+          </a:p>
+        </p:txBody>
+      </p:sp>
+      <p:sp>
+        <p:nvSpPr>
+          <p:cNvPr id="7" name="Rectangle 6"/>
+          <p:cNvSpPr/>
+          <p:nvPr/>
+        </p:nvSpPr>
+        <p:spPr>
+          <a:xfrm>
+            <a:off x="457200" y="6419088"/>
+            <a:ext cx="5486400" cy="274320"/>
+          </a:xfrm>
+          <a:prstGeom prst="rect">
+            <a:avLst/>
+          </a:prstGeom>
+          <a:noFill/>
+          <a:ln>
+            <a:noFill/>
+          </a:ln>
+          <a:effectLst/>
+        </p:spPr>
+        <p:style>
+          <a:lnRef idx="1">
+            <a:schemeClr val="accent1"/>
+          </a:lnRef>
+          <a:fillRef idx="3">
+            <a:schemeClr val="accent1"/>
+          </a:fillRef>
+          <a:effectRef idx="2">
+            <a:schemeClr val="accent1"/>
+          </a:effectRef>
+          <a:fontRef idx="minor">
+            <a:schemeClr val="lt1"/>
+          </a:fontRef>
+        </p:style>
+        <p:txBody>
+          <a:bodyPr rtlCol="0" anchor="t" wrap="square" lIns="73152" rIns="73152" tIns="27432" bIns="27432"/>
+          <a:lstStyle/>
+          <a:p>
+            <a:pPr algn="l">
+              <a:spcBef>
+                <a:spcPts val="0"/>
+              </a:spcBef>
+              <a:spcAft>
+                <a:spcPts val="200"/>
+              </a:spcAft>
+            </a:pPr>
+            <a:r>
+              <a:rPr sz="900" b="0">
+                <a:solidFill>
+                  <a:srgbClr val="6B7686"/>
+                </a:solidFill>
+                <a:latin typeface="Meiryo"/>
+              </a:rPr>
+              <a:t>短時間勤務者採用 説明会</a:t>
+            </a:r>
+          </a:p>
+        </p:txBody>
+      </p:sp>
+      <p:sp>
+        <p:nvSpPr>
+          <p:cNvPr id="8" name="Rectangle 7"/>
+          <p:cNvSpPr/>
+          <p:nvPr/>
+        </p:nvSpPr>
+        <p:spPr>
+          <a:xfrm>
+            <a:off x="11155680" y="6419088"/>
+            <a:ext cx="640080" cy="274320"/>
+          </a:xfrm>
+          <a:prstGeom prst="rect">
+            <a:avLst/>
+          </a:prstGeom>
+          <a:noFill/>
+          <a:ln>
+            <a:noFill/>
+          </a:ln>
+          <a:effectLst/>
+        </p:spPr>
+        <p:style>
+          <a:lnRef idx="1">
+            <a:schemeClr val="accent1"/>
+          </a:lnRef>
+          <a:fillRef idx="3">
+            <a:schemeClr val="accent1"/>
+          </a:fillRef>
+          <a:effectRef idx="2">
+            <a:schemeClr val="accent1"/>
+          </a:effectRef>
+          <a:fontRef idx="minor">
+            <a:schemeClr val="lt1"/>
+          </a:fontRef>
+        </p:style>
+        <p:txBody>
+          <a:bodyPr rtlCol="0" anchor="t" wrap="square" lIns="73152" rIns="73152" tIns="27432" bIns="27432"/>
+          <a:lstStyle/>
+          <a:p>
+            <a:pPr algn="r">
+              <a:spcBef>
+                <a:spcPts val="0"/>
+              </a:spcBef>
+              <a:spcAft>
+                <a:spcPts val="200"/>
+              </a:spcAft>
+            </a:pPr>
+            <a:r>
+              <a:rPr sz="900" b="0">
+                <a:solidFill>
+                  <a:srgbClr val="6B7686"/>
+                </a:solidFill>
+                <a:latin typeface="Meiryo"/>
+              </a:rPr>
+              <a:t>21</a:t>
+            </a:r>
           </a:p>
         </p:txBody>
       </p:sp>

</xml_diff>

<commit_message>
Convert amounts to 億・万円 notation and rebuild slide7 chart
- 背景①〜④ money figures reformatted to 億・万円 for easy reading aloud
  (e.g. 売上 1億7,800万円 / 原価 1億8,300万円 / 営業損益 ▲1,730万円/月 /
  全社 ▲5,800万円/月); on-screen identities preserved; notes updated to match
- Rebuild slide7 base-comparison chart natively with python-pptx: the earlier
  replace_data left XML that passed XSD but PowerPoint refused to render (chart
  appeared blank). Fresh native chart renders reliably; values in 万円

Co-Authored-By: Claude Opus 4.8 <noreply@anthropic.com>
Claude-Session: https://claude.ai/code/session_01QArHsAp1PFHsh5bJQQbheX
</commit_message>
<xml_diff>
--- a/成田_短時間勤務者採用_説明会.pptx
+++ b/成田_短時間勤務者採用_説明会.pptx
@@ -611,22 +611,22 @@
                 <c:formatCode>General</c:formatCode>
                 <c:ptCount val="6"/>
                 <c:pt idx="0">
-                  <c:v>7.6</c:v>
+                  <c:v>760</c:v>
                 </c:pt>
                 <c:pt idx="1">
-                  <c:v>3.3</c:v>
+                  <c:v>330</c:v>
                 </c:pt>
                 <c:pt idx="2">
-                  <c:v>1.3</c:v>
+                  <c:v>130</c:v>
                 </c:pt>
                 <c:pt idx="3">
-                  <c:v>0.0</c:v>
+                  <c:v>0</c:v>
                 </c:pt>
                 <c:pt idx="4">
-                  <c:v>-7.7</c:v>
+                  <c:v>-770</c:v>
                 </c:pt>
                 <c:pt idx="5">
-                  <c:v>-17.3</c:v>
+                  <c:v>-1730</c:v>
                 </c:pt>
               </c:numCache>
             </c:numRef>
@@ -1091,6 +1091,193 @@
 </c:chartSpace>
 </file>
 
+<file path=ppt/charts/chart4.xml><?xml version="1.0" encoding="utf-8"?>
+<c:chartSpace xmlns:c="http://schemas.openxmlformats.org/drawingml/2006/chart" xmlns:a="http://schemas.openxmlformats.org/drawingml/2006/main" xmlns:r="http://schemas.openxmlformats.org/officeDocument/2006/relationships">
+  <c:date1904 val="0"/>
+  <c:chart>
+    <c:autoTitleDeleted val="1"/>
+    <c:plotArea>
+      <c:barChart>
+        <c:barDir val="bar"/>
+        <c:grouping val="clustered"/>
+        <c:varyColors val="0"/>
+        <c:ser>
+          <c:idx val="0"/>
+          <c:order val="0"/>
+          <c:tx>
+            <c:strRef>
+              <c:f>Sheet1!$B$1</c:f>
+              <c:strCache>
+                <c:ptCount val="1"/>
+                <c:pt idx="0">
+                  <c:v>旅客 営業損益</c:v>
+                </c:pt>
+              </c:strCache>
+            </c:strRef>
+          </c:tx>
+          <c:spPr>
+            <a:solidFill>
+              <a:srgbClr val="1E7A5A"/>
+            </a:solidFill>
+          </c:spPr>
+          <c:cat>
+            <c:strRef>
+              <c:f>Sheet1!$A$2:$A$7</c:f>
+              <c:strCache>
+                <c:ptCount val="6"/>
+                <c:pt idx="0">
+                  <c:v>那覇</c:v>
+                </c:pt>
+                <c:pt idx="1">
+                  <c:v>羽田</c:v>
+                </c:pt>
+                <c:pt idx="2">
+                  <c:v>千歳</c:v>
+                </c:pt>
+                <c:pt idx="3">
+                  <c:v>北九州</c:v>
+                </c:pt>
+                <c:pt idx="4">
+                  <c:v>関空</c:v>
+                </c:pt>
+                <c:pt idx="5">
+                  <c:v>成田</c:v>
+                </c:pt>
+              </c:strCache>
+            </c:strRef>
+          </c:cat>
+          <c:val>
+            <c:numRef>
+              <c:f>Sheet1!$B$2:$B$7</c:f>
+              <c:numCache>
+                <c:formatCode>General</c:formatCode>
+                <c:ptCount val="6"/>
+                <c:pt idx="0">
+                  <c:v>760</c:v>
+                </c:pt>
+                <c:pt idx="1">
+                  <c:v>330</c:v>
+                </c:pt>
+                <c:pt idx="2">
+                  <c:v>130</c:v>
+                </c:pt>
+                <c:pt idx="3">
+                  <c:v>0</c:v>
+                </c:pt>
+                <c:pt idx="4">
+                  <c:v>-770</c:v>
+                </c:pt>
+                <c:pt idx="5">
+                  <c:v>-1730</c:v>
+                </c:pt>
+              </c:numCache>
+            </c:numRef>
+          </c:val>
+        </c:ser>
+        <c:dLbls>
+          <c:numFmt formatCode="#,##0" sourceLinked="0"/>
+          <c:txPr>
+            <a:bodyPr/>
+            <a:lstStyle/>
+            <a:p>
+              <a:pPr>
+                <a:defRPr sz="1100" b="1">
+                  <a:solidFill>
+                    <a:srgbClr val="1F2733"/>
+                  </a:solidFill>
+                  <a:latin typeface="Meiryo"/>
+                </a:defRPr>
+              </a:pPr>
+            </a:p>
+          </c:txPr>
+          <c:showLegendKey val="0"/>
+          <c:showVal val="1"/>
+          <c:showCatName val="0"/>
+          <c:showSerName val="0"/>
+          <c:showPercent val="0"/>
+          <c:showBubbleSize val="0"/>
+          <c:showLeaderLines val="1"/>
+        </c:dLbls>
+        <c:gapWidth/>
+        <c:axId val="-2068027336"/>
+        <c:axId val="-2113994440"/>
+      </c:barChart>
+      <c:catAx>
+        <c:axId val="-2068027336"/>
+        <c:scaling>
+          <c:orientation val="minMax"/>
+        </c:scaling>
+        <c:delete val="0"/>
+        <c:axPos val="l"/>
+        <c:majorTickMark val="out"/>
+        <c:minorTickMark val="none"/>
+        <c:tickLblPos val="nextTo"/>
+        <c:txPr>
+          <a:bodyPr/>
+          <a:lstStyle/>
+          <a:p>
+            <a:pPr>
+              <a:defRPr sz="1000">
+                <a:solidFill>
+                  <a:srgbClr val="6B7686"/>
+                </a:solidFill>
+                <a:latin typeface="Meiryo"/>
+              </a:defRPr>
+            </a:pPr>
+          </a:p>
+        </c:txPr>
+        <c:crossAx val="-2113994440"/>
+        <c:crosses val="autoZero"/>
+        <c:auto val="1"/>
+        <c:lblAlgn val="ctr"/>
+        <c:lblOffset val="100"/>
+        <c:noMultiLvlLbl val="0"/>
+      </c:catAx>
+      <c:valAx>
+        <c:axId val="-2113994440"/>
+        <c:scaling/>
+        <c:delete val="0"/>
+        <c:axPos val="b"/>
+        <c:majorGridlines/>
+        <c:majorTickMark val="out"/>
+        <c:minorTickMark val="none"/>
+        <c:tickLblPos val="nextTo"/>
+        <c:txPr>
+          <a:bodyPr/>
+          <a:lstStyle/>
+          <a:p>
+            <a:pPr>
+              <a:defRPr sz="1000">
+                <a:solidFill>
+                  <a:srgbClr val="6B7686"/>
+                </a:solidFill>
+                <a:latin typeface="Meiryo"/>
+              </a:defRPr>
+            </a:pPr>
+          </a:p>
+        </c:txPr>
+        <c:crossAx val="-2068027336"/>
+        <c:crosses val="autoZero"/>
+      </c:valAx>
+    </c:plotArea>
+    <c:dispBlanksAs val="gap"/>
+  </c:chart>
+  <c:txPr>
+    <a:bodyPr/>
+    <a:lstStyle/>
+    <a:p>
+      <a:pPr>
+        <a:defRPr sz="1800"/>
+      </a:pPr>
+      <a:endParaRPr lang="en-US"/>
+    </a:p>
+  </c:txPr>
+  <c:externalData r:id="rId1">
+    <c:autoUpdate val="0"/>
+  </c:externalData>
+</c:chartSpace>
+</file>
+
 <file path=ppt/notesMasters/notesMaster1.xml><?xml version="1.0" encoding="utf-8"?>
 <p:notesMaster xmlns:a="http://schemas.openxmlformats.org/drawingml/2006/main" xmlns:r="http://schemas.openxmlformats.org/officeDocument/2006/relationships" xmlns:p="http://schemas.openxmlformats.org/presentationml/2006/main">
   <p:cSld>
@@ -3667,7 +3854,7 @@
           <a:p>
             <a:r>
               <a:rPr lang="en-US" dirty="0"/>
-              <a:t>旅客部門だけを抜き出すと、売上178百万に対して売上原価が182百万。販管費を引く前、原価だけで売上を超えています。これが原価割れです。営業損益では月17百万円の赤字、年に直すと約2.1億円の赤字になります。</a:t>
+              <a:t>旅客部門だけを抜き出すと、売上1億7,800万に対して売上原価が1億8,300万。販管費を引く前、原価だけで売上を超えています。これが原価割れです。営業損益では月1,730万円の赤字、年に直すと約2億1,000万円の赤字になります。</a:t>
             </a:r>
             <a:endParaRPr lang="en-US" dirty="0"/>
           </a:p>
@@ -3931,7 +4118,7 @@
           <a:p>
             <a:r>
               <a:rPr lang="en-US" dirty="0"/>
-              <a:t>全社で見ると、営業赤字はおよそ月58百万円。そのうち成田の旅客部門だけで約3割、成田全部門では約6割を占めます。つまり、成田を直さなければ全社の収支は直らない、というのが今の姿です。</a:t>
+              <a:t>全社で見ると、営業赤字はおよそ月5,800万円。そのうち成田の旅客部門だけで約3割、成田全部門では約6割を占めます。つまり、成田を直さなければ全社の収支は直らない、というのが今の姿です。</a:t>
             </a:r>
             <a:endParaRPr lang="en-US" dirty="0"/>
           </a:p>
@@ -31941,7 +32128,7 @@
                 <a:ea typeface="Meiryo" pitchFamily="34" charset="-122"/>
                 <a:cs typeface="Meiryo" pitchFamily="34" charset="-120"/>
               </a:rPr>
-              <a:t>2026年5月 実績・旅客部門のみ（単位：百万円）</a:t>
+              <a:t>2026年5月 実績・旅客部門のみ（金額は億・万円で表記）</a:t>
             </a:r>
             <a:endParaRPr lang="en-US" sz="1200" dirty="0"/>
           </a:p>
@@ -32057,7 +32244,7 @@
                 <a:ea typeface="Meiryo" pitchFamily="34" charset="-122"/>
                 <a:cs typeface="Meiryo" pitchFamily="34" charset="-120"/>
               </a:rPr>
-              <a:t>▲17.3</a:t>
+              <a:t>▲1,730</a:t>
             </a:r>
             <a:pPr indent="0" marL="0">
               <a:buNone/>
@@ -32071,7 +32258,7 @@
                 <a:ea typeface="Meiryo" pitchFamily="34" charset="-122"/>
                 <a:cs typeface="Meiryo" pitchFamily="34" charset="-120"/>
               </a:rPr>
-              <a:t> 百万円 / 月</a:t>
+              <a:t>万円 / 月</a:t>
             </a:r>
             <a:endParaRPr lang="en-US" sz="4000" dirty="0"/>
           </a:p>
@@ -32395,7 +32582,7 @@
                 <a:ea typeface="Meiryo" pitchFamily="34" charset="-122"/>
                 <a:cs typeface="Meiryo" pitchFamily="34" charset="-120"/>
               </a:rPr>
-              <a:t>約 ▲2.1</a:t>
+              <a:t>約 ▲2億1,000</a:t>
             </a:r>
             <a:pPr indent="0" marL="0">
               <a:buNone/>
@@ -32409,7 +32596,7 @@
                 <a:ea typeface="Meiryo" pitchFamily="34" charset="-122"/>
                 <a:cs typeface="Meiryo" pitchFamily="34" charset="-120"/>
               </a:rPr>
-              <a:t> 億円</a:t>
+              <a:t>万円</a:t>
             </a:r>
             <a:endParaRPr lang="en-US" sz="4000" dirty="0"/>
           </a:p>
@@ -32448,7 +32635,7 @@
                 <a:ea typeface="Meiryo" pitchFamily="34" charset="-122"/>
                 <a:cs typeface="Meiryo" pitchFamily="34" charset="-120"/>
               </a:rPr>
-              <a:t>▲17.3百万円 × 12ヶ月</a:t>
+              <a:t>▲1,730万円 × 12ヶ月</a:t>
             </a:r>
             <a:endParaRPr lang="en-US" sz="1250" dirty="0"/>
           </a:p>
@@ -32549,7 +32736,7 @@
                 <a:ea typeface="Meiryo" pitchFamily="34" charset="-122"/>
                 <a:cs typeface="Meiryo" pitchFamily="34" charset="-120"/>
               </a:rPr>
-              <a:t>売上 178.1  −  売上原価 182.8  =  </a:t>
+              <a:t>売上 1億7,800万  −  売上原価 1億8,300万  =  </a:t>
             </a:r>
             <a:pPr indent="0" marL="0">
               <a:buNone/>
@@ -32563,7 +32750,7 @@
                 <a:ea typeface="Meiryo" pitchFamily="34" charset="-122"/>
                 <a:cs typeface="Meiryo" pitchFamily="34" charset="-120"/>
               </a:rPr>
-              <a:t>売上総損益 ▲4.8百万円</a:t>
+              <a:t>売上総損益 ▲500万円</a:t>
             </a:r>
             <a:endParaRPr lang="en-US" sz="1600" dirty="0"/>
           </a:p>
@@ -32602,7 +32789,7 @@
                 <a:ea typeface="Meiryo" pitchFamily="34" charset="-122"/>
                 <a:cs typeface="Meiryo" pitchFamily="34" charset="-120"/>
               </a:rPr>
-              <a:t>販管費（12.6百万円）を引く前の段階で、すでに赤字。まさに「原価割れ」です。</a:t>
+              <a:t>販管費（1,300万円）を引く前の段階で、すでに赤字。まさに「原価割れ」です。</a:t>
             </a:r>
             <a:endParaRPr lang="en-US" sz="1350" dirty="0"/>
           </a:p>
@@ -33000,7 +33187,7 @@
                 <a:ea typeface="Meiryo" pitchFamily="34" charset="-122"/>
                 <a:cs typeface="Meiryo" pitchFamily="34" charset="-120"/>
               </a:rPr>
-              <a:t>107.5百万円</a:t>
+              <a:t>1億700万円</a:t>
             </a:r>
             <a:endParaRPr lang="en-US" sz="1250" dirty="0"/>
           </a:p>
@@ -33155,7 +33342,7 @@
                 <a:ea typeface="Meiryo" pitchFamily="34" charset="-122"/>
                 <a:cs typeface="Meiryo" pitchFamily="34" charset="-120"/>
               </a:rPr>
-              <a:t>54.7百万円</a:t>
+              <a:t>5,500万円</a:t>
             </a:r>
             <a:endParaRPr lang="en-US" sz="1250" dirty="0"/>
           </a:p>
@@ -33310,7 +33497,7 @@
                 <a:ea typeface="Meiryo" pitchFamily="34" charset="-122"/>
                 <a:cs typeface="Meiryo" pitchFamily="34" charset="-120"/>
               </a:rPr>
-              <a:t>162.1百万円</a:t>
+              <a:t>1億6,200万円</a:t>
             </a:r>
             <a:endParaRPr lang="en-US" sz="1250" dirty="0"/>
           </a:p>
@@ -33543,22 +33730,6 @@
           </a:p>
         </p:txBody>
       </p:sp>
-      <p:graphicFrame>
-        <p:nvGraphicFramePr>
-          <p:cNvPr id="4" name="Chart 0" descr=""/>
-          <p:cNvGraphicFramePr/>
-          <p:nvPr/>
-        </p:nvGraphicFramePr>
-        <p:xfrm>
-          <a:off x="548640" y="2148840"/>
-          <a:ext cx="7406640" cy="3886200"/>
-        </p:xfrm>
-        <a:graphic xmlns:a="http://schemas.openxmlformats.org/drawingml/2006/main">
-          <a:graphicData uri="http://schemas.openxmlformats.org/drawingml/2006/chart">
-            <c:chart xmlns:c="http://schemas.openxmlformats.org/drawingml/2006/chart" r:id="rId1"/>
-          </a:graphicData>
-        </a:graphic>
-      </p:graphicFrame>
       <p:sp>
         <p:nvSpPr>
           <p:cNvPr id="5" name="Text 2"/>
@@ -33592,7 +33763,7 @@
                 <a:ea typeface="Meiryo" pitchFamily="34" charset="-122"/>
                 <a:cs typeface="Meiryo" pitchFamily="34" charset="-120"/>
               </a:rPr>
-              <a:t>旅客部門のみ・営業損益（百万円/月）</a:t>
+              <a:t>旅客部門のみ・営業損益（万円/月）</a:t>
             </a:r>
             <a:endParaRPr lang="en-US" sz="1100" dirty="0"/>
           </a:p>
@@ -33732,7 +33903,7 @@
                 <a:ea typeface="Meiryo" pitchFamily="34" charset="-122"/>
                 <a:cs typeface="Meiryo" pitchFamily="34" charset="-120"/>
               </a:rPr>
-              <a:t>▲17.3</a:t>
+              <a:t>▲1,730</a:t>
             </a:r>
             <a:endParaRPr lang="en-US" sz="4000" dirty="0"/>
           </a:p>
@@ -33771,7 +33942,7 @@
                 <a:ea typeface="Meiryo" pitchFamily="34" charset="-122"/>
                 <a:cs typeface="Meiryo" pitchFamily="34" charset="-120"/>
               </a:rPr>
-              <a:t>百万円 / 月</a:t>
+              <a:t>万円 / 月</a:t>
             </a:r>
             <a:endParaRPr lang="en-US" sz="1400" dirty="0"/>
           </a:p>
@@ -33924,6 +34095,24 @@
           </a:p>
         </p:txBody>
       </p:sp>
+      <p:graphicFrame>
+        <p:nvGraphicFramePr>
+          <p:cNvPr id="15" name="Chart 14"/>
+          <p:cNvGraphicFramePr>
+            <a:graphicFrameLocks noGrp="1"/>
+          </p:cNvGraphicFramePr>
+          <p:nvPr/>
+        </p:nvGraphicFramePr>
+        <p:xfrm>
+          <a:off x="548640" y="2148840"/>
+          <a:ext cx="7406640" cy="3886200"/>
+        </p:xfrm>
+        <a:graphic>
+          <a:graphicData uri="http://schemas.openxmlformats.org/drawingml/2006/chart">
+            <c:chart xmlns:c="http://schemas.openxmlformats.org/drawingml/2006/chart" r:id="rId4"/>
+          </a:graphicData>
+        </a:graphic>
+      </p:graphicFrame>
     </p:spTree>
   </p:cSld>
   <p:clrMapOvr>
@@ -34186,7 +34375,7 @@
                 <a:ea typeface="Meiryo" pitchFamily="34" charset="-122"/>
                 <a:cs typeface="Meiryo" pitchFamily="34" charset="-120"/>
               </a:rPr>
-              <a:t>全社営業赤字（▲58.0百万円/月）に占める割合</a:t>
+              <a:t>全社営業赤字（▲5,800万円/月）に占める割合</a:t>
             </a:r>
             <a:endParaRPr lang="en-US" sz="1250" dirty="0"/>
           </a:p>

</xml_diff>